<commit_message>
Ilustrações no slide da Primeira Revolução Industrial
Troca as formas decorativas abstratas da capa e do fechamento por
ilustrações que dizem alguma coisa, e coloca imagem em mais três slides.

Cinco desenhos em vetor, feitos na paleta do próprio deck: fábrica com
chaminés e janelas acesas, máquina a vapor de balancim com caldeira e
volante, tear mecânico com a lançadeira atravessando os fios, locomotiva
sobre trilhos e roda d'água.

Não usei imagem de banco nem de busca: seriam de terceiros, com
licença a verificar. Desenho próprio resolve o direito de uso e fica
coerente com o resto do deck.

O slide 5 foi reestruturado para abrir espaço ao tear, com os números
virando faixa no rodapé, e o slide 6 teve os painéis reequilibrados
para a locomotiva caber sem encostar no título.
</commit_message>
<xml_diff>
--- a/docs/primeira-revolucao-industrial.pptx
+++ b/docs/primeira-revolucao-industrial.pptx
@@ -1129,7 +1129,7 @@
           <a:p>
             <a:r>
               <a:rPr lang="en-US" dirty="0"/>
-              <a:t>Ponto simples: a revolução não começou em tudo ao mesmo tempo, começou no tecido. Por quê? Porque roupa todo mundo precisa, e fiar à mão era lentíssimo. Era o maior gargalo da época, então foi onde a máquina valeu mais a pena primeiro.</a:t>
+              <a:t>Ponto simples: a revolução não começou em tudo ao mesmo tempo, começou no tecido. Por quê? Porque roupa todo mundo precisa, e fiar à mão era lentíssimo. Era o maior gargalo da época, então foi onde a máquina valeu mais a pena primeiro. Aponte para o desenho: a lançadeira é a peça que atravessa os fios — antes era a mão de alguém.</a:t>
             </a:r>
             <a:endParaRPr lang="en-US" dirty="0"/>
           </a:p>
@@ -2053,56 +2053,40 @@
           </a:p>
         </p:txBody>
       </p:sp>
-      <p:sp>
-        <p:nvSpPr>
-          <p:cNvPr id="6" name="Shape 4"/>
-          <p:cNvSpPr/>
-          <p:nvPr/>
-        </p:nvSpPr>
-        <p:spPr>
-          <a:xfrm>
-            <a:off x="8686800" y="1691640"/>
-            <a:ext cx="2926080" cy="2926080"/>
-          </a:xfrm>
-          <a:prstGeom prst="ellipse">
-            <a:avLst/>
-          </a:prstGeom>
-          <a:solidFill>
-            <a:srgbClr val="332B27"/>
-          </a:solidFill>
-          <a:ln/>
-        </p:spPr>
-      </p:sp>
-      <p:sp>
-        <p:nvSpPr>
-          <p:cNvPr id="7" name="Shape 5"/>
-          <p:cNvSpPr/>
-          <p:nvPr/>
-        </p:nvSpPr>
-        <p:spPr>
-          <a:xfrm>
-            <a:off x="9464040" y="2468880"/>
-            <a:ext cx="1371600" cy="1371600"/>
-          </a:xfrm>
-          <a:prstGeom prst="ellipse">
-            <a:avLst/>
-          </a:prstGeom>
-          <a:solidFill>
-            <a:srgbClr val="D4661F"/>
-          </a:solidFill>
-          <a:ln/>
-        </p:spPr>
-      </p:sp>
-      <p:sp>
-        <p:nvSpPr>
-          <p:cNvPr id="8" name="Text 6"/>
-          <p:cNvSpPr/>
-          <p:nvPr/>
-        </p:nvSpPr>
-        <p:spPr>
-          <a:xfrm>
-            <a:off x="8686800" y="4800600"/>
-            <a:ext cx="2926080" cy="365760"/>
+      <p:pic>
+        <p:nvPicPr>
+          <p:cNvPr id="6" name="Image 0" descr="/tmp/claude-0/-home-user-industry/243a34b7-d02b-5193-b717-6e82dfe9a345/scratchpad/img/fabrica-escura.png">    </p:cNvPr>
+          <p:cNvPicPr>
+            <a:picLocks noChangeAspect="1"/>
+          </p:cNvPicPr>
+          <p:nvPr/>
+        </p:nvPicPr>
+        <p:blipFill>
+          <a:blip r:embed="rId1"/>
+          <a:stretch>
+            <a:fillRect/>
+          </a:stretch>
+        </p:blipFill>
+        <p:spPr>
+          <a:xfrm>
+            <a:off x="8092440" y="1600200"/>
+            <a:ext cx="3749040" cy="2856411"/>
+          </a:xfrm>
+          <a:prstGeom prst="rect">
+            <a:avLst/>
+          </a:prstGeom>
+        </p:spPr>
+      </p:pic>
+      <p:sp>
+        <p:nvSpPr>
+          <p:cNvPr id="7" name="Text 4"/>
+          <p:cNvSpPr/>
+          <p:nvPr/>
+        </p:nvSpPr>
+        <p:spPr>
+          <a:xfrm>
+            <a:off x="8092440" y="4892040"/>
+            <a:ext cx="3749040" cy="365760"/>
           </a:xfrm>
           <a:prstGeom prst="rect">
             <a:avLst/>
@@ -2118,17 +2102,17 @@
               <a:buNone/>
             </a:pPr>
             <a:r>
-              <a:rPr lang="en-US" sz="1600" b="1" dirty="0">
+              <a:rPr lang="en-US" sz="1250" i="1" dirty="0">
                 <a:solidFill>
                   <a:srgbClr val="9A8E82"/>
                 </a:solidFill>
-                <a:latin typeface="Bookman Old Style" pitchFamily="34" charset="0"/>
-                <a:ea typeface="Bookman Old Style" pitchFamily="34" charset="-122"/>
-                <a:cs typeface="Bookman Old Style" pitchFamily="34" charset="-120"/>
-              </a:rPr>
-              <a:t>1769</a:t>
-            </a:r>
-            <a:endParaRPr lang="en-US" sz="1600" dirty="0"/>
+                <a:latin typeface="Calibri" pitchFamily="34" charset="0"/>
+                <a:ea typeface="Calibri" pitchFamily="34" charset="-122"/>
+                <a:cs typeface="Calibri" pitchFamily="34" charset="-120"/>
+              </a:rPr>
+              <a:t>A fábrica: a invenção que veio junto</a:t>
+            </a:r>
+            <a:endParaRPr lang="en-US" sz="1250" dirty="0"/>
           </a:p>
         </p:txBody>
       </p:sp>
@@ -3664,49 +3648,33 @@
           <a:chExt cx="0" cy="0"/>
         </a:xfrm>
       </p:grpSpPr>
-      <p:sp>
-        <p:nvSpPr>
-          <p:cNvPr id="2" name="Shape 0"/>
-          <p:cNvSpPr/>
-          <p:nvPr/>
-        </p:nvSpPr>
-        <p:spPr>
-          <a:xfrm>
-            <a:off x="9235440" y="1371600"/>
-            <a:ext cx="2194560" cy="2194560"/>
-          </a:xfrm>
-          <a:prstGeom prst="ellipse">
-            <a:avLst/>
-          </a:prstGeom>
-          <a:solidFill>
-            <a:srgbClr val="332B27"/>
-          </a:solidFill>
-          <a:ln/>
-        </p:spPr>
-      </p:sp>
-      <p:sp>
-        <p:nvSpPr>
-          <p:cNvPr id="3" name="Shape 1"/>
-          <p:cNvSpPr/>
-          <p:nvPr/>
-        </p:nvSpPr>
-        <p:spPr>
-          <a:xfrm>
-            <a:off x="9829800" y="1965960"/>
-            <a:ext cx="1005840" cy="1005840"/>
-          </a:xfrm>
-          <a:prstGeom prst="ellipse">
-            <a:avLst/>
-          </a:prstGeom>
-          <a:solidFill>
-            <a:srgbClr val="D4661F"/>
-          </a:solidFill>
-          <a:ln/>
-        </p:spPr>
-      </p:sp>
-      <p:sp>
-        <p:nvSpPr>
-          <p:cNvPr id="4" name="Text 2"/>
+      <p:pic>
+        <p:nvPicPr>
+          <p:cNvPr id="2" name="Image 0" descr="/tmp/claude-0/-home-user-industry/243a34b7-d02b-5193-b717-6e82dfe9a345/scratchpad/img/fabrica-escura.png">    </p:cNvPr>
+          <p:cNvPicPr>
+            <a:picLocks noChangeAspect="1"/>
+          </p:cNvPicPr>
+          <p:nvPr/>
+        </p:nvPicPr>
+        <p:blipFill>
+          <a:blip r:embed="rId1"/>
+          <a:stretch>
+            <a:fillRect/>
+          </a:stretch>
+        </p:blipFill>
+        <p:spPr>
+          <a:xfrm>
+            <a:off x="8549640" y="1737360"/>
+            <a:ext cx="3200400" cy="2438400"/>
+          </a:xfrm>
+          <a:prstGeom prst="rect">
+            <a:avLst/>
+          </a:prstGeom>
+        </p:spPr>
+      </p:pic>
+      <p:sp>
+        <p:nvSpPr>
+          <p:cNvPr id="3" name="Text 0"/>
           <p:cNvSpPr/>
           <p:nvPr/>
         </p:nvSpPr>
@@ -3745,7 +3713,7 @@
       </p:sp>
       <p:sp>
         <p:nvSpPr>
-          <p:cNvPr id="5" name="Text 3"/>
+          <p:cNvPr id="4" name="Text 1"/>
           <p:cNvSpPr/>
           <p:nvPr/>
         </p:nvSpPr>
@@ -3807,7 +3775,7 @@
       </p:sp>
       <p:sp>
         <p:nvSpPr>
-          <p:cNvPr id="6" name="Shape 4"/>
+          <p:cNvPr id="5" name="Shape 2"/>
           <p:cNvSpPr/>
           <p:nvPr/>
         </p:nvSpPr>
@@ -3827,7 +3795,7 @@
       </p:sp>
       <p:sp>
         <p:nvSpPr>
-          <p:cNvPr id="7" name="Text 5"/>
+          <p:cNvPr id="6" name="Text 3"/>
           <p:cNvSpPr/>
           <p:nvPr/>
         </p:nvSpPr>
@@ -3866,7 +3834,7 @@
       </p:sp>
       <p:sp>
         <p:nvSpPr>
-          <p:cNvPr id="8" name="Text 6"/>
+          <p:cNvPr id="7" name="Text 4"/>
           <p:cNvSpPr/>
           <p:nvPr/>
         </p:nvSpPr>
@@ -4847,20 +4815,44 @@
           </a:p>
         </p:txBody>
       </p:sp>
-      <p:sp>
-        <p:nvSpPr>
-          <p:cNvPr id="6" name="Shape 4"/>
-          <p:cNvSpPr/>
-          <p:nvPr/>
-        </p:nvSpPr>
-        <p:spPr>
-          <a:xfrm>
-            <a:off x="6858000" y="1371600"/>
-            <a:ext cx="4645152" cy="4206240"/>
+      <p:pic>
+        <p:nvPicPr>
+          <p:cNvPr id="6" name="Image 0" descr="/tmp/claude-0/-home-user-industry/243a34b7-d02b-5193-b717-6e82dfe9a345/scratchpad/img/maquina-vapor.png">    </p:cNvPr>
+          <p:cNvPicPr>
+            <a:picLocks noChangeAspect="1"/>
+          </p:cNvPicPr>
+          <p:nvPr/>
+        </p:nvPicPr>
+        <p:blipFill>
+          <a:blip r:embed="rId1"/>
+          <a:stretch>
+            <a:fillRect/>
+          </a:stretch>
+        </p:blipFill>
+        <p:spPr>
+          <a:xfrm>
+            <a:off x="7086600" y="960120"/>
+            <a:ext cx="4297680" cy="3274423"/>
+          </a:xfrm>
+          <a:prstGeom prst="rect">
+            <a:avLst/>
+          </a:prstGeom>
+        </p:spPr>
+      </p:pic>
+      <p:sp>
+        <p:nvSpPr>
+          <p:cNvPr id="7" name="Shape 4"/>
+          <p:cNvSpPr/>
+          <p:nvPr/>
+        </p:nvSpPr>
+        <p:spPr>
+          <a:xfrm>
+            <a:off x="6858000" y="4343400"/>
+            <a:ext cx="4645152" cy="1783080"/>
           </a:xfrm>
           <a:prstGeom prst="roundRect">
             <a:avLst>
-              <a:gd name="adj" fmla="val 2609"/>
+              <a:gd name="adj" fmla="val 6154"/>
             </a:avLst>
           </a:prstGeom>
           <a:solidFill>
@@ -4871,30 +4863,30 @@
       </p:sp>
       <p:sp>
         <p:nvSpPr>
-          <p:cNvPr id="7" name="Text 5"/>
-          <p:cNvSpPr/>
-          <p:nvPr/>
-        </p:nvSpPr>
-        <p:spPr>
-          <a:xfrm>
-            <a:off x="7269480" y="1783080"/>
-            <a:ext cx="3840480" cy="320040"/>
-          </a:xfrm>
-          <a:prstGeom prst="rect">
-            <a:avLst/>
-          </a:prstGeom>
-          <a:noFill/>
-          <a:ln/>
-        </p:spPr>
-        <p:txBody>
-          <a:bodyPr wrap="square" lIns="0" tIns="0" rIns="0" bIns="0" rtlCol="0" anchor="ctr"/>
-          <a:lstStyle/>
-          <a:p>
-            <a:pPr indent="0" marL="0">
-              <a:buNone/>
-            </a:pPr>
-            <a:r>
-              <a:rPr lang="en-US" sz="1300" b="1" spc="200" kern="0" dirty="0">
+          <p:cNvPr id="8" name="Text 5"/>
+          <p:cNvSpPr/>
+          <p:nvPr/>
+        </p:nvSpPr>
+        <p:spPr>
+          <a:xfrm>
+            <a:off x="7269480" y="4617720"/>
+            <a:ext cx="3840480" cy="274320"/>
+          </a:xfrm>
+          <a:prstGeom prst="rect">
+            <a:avLst/>
+          </a:prstGeom>
+          <a:noFill/>
+          <a:ln/>
+        </p:spPr>
+        <p:txBody>
+          <a:bodyPr wrap="square" lIns="0" tIns="0" rIns="0" bIns="0" rtlCol="0" anchor="ctr"/>
+          <a:lstStyle/>
+          <a:p>
+            <a:pPr indent="0" marL="0">
+              <a:buNone/>
+            </a:pPr>
+            <a:r>
+              <a:rPr lang="en-US" sz="1250" b="1" spc="200" kern="0" dirty="0">
                 <a:solidFill>
                   <a:srgbClr val="D4661F"/>
                 </a:solidFill>
@@ -4904,36 +4896,36 @@
               </a:rPr>
               <a:t>Por que isso muda tudo</a:t>
             </a:r>
-            <a:endParaRPr lang="en-US" sz="1300" dirty="0"/>
-          </a:p>
-        </p:txBody>
-      </p:sp>
-      <p:sp>
-        <p:nvSpPr>
-          <p:cNvPr id="8" name="Text 6"/>
-          <p:cNvSpPr/>
-          <p:nvPr/>
-        </p:nvSpPr>
-        <p:spPr>
-          <a:xfrm>
-            <a:off x="7269480" y="2286000"/>
-            <a:ext cx="3840480" cy="1188720"/>
-          </a:xfrm>
-          <a:prstGeom prst="rect">
-            <a:avLst/>
-          </a:prstGeom>
-          <a:noFill/>
-          <a:ln/>
-        </p:spPr>
-        <p:txBody>
-          <a:bodyPr wrap="square" lIns="0" tIns="0" rIns="0" bIns="0" rtlCol="0" anchor="ctr"/>
-          <a:lstStyle/>
-          <a:p>
-            <a:pPr indent="0" marL="0">
-              <a:buNone/>
-            </a:pPr>
-            <a:r>
-              <a:rPr lang="en-US" sz="1500" dirty="0">
+            <a:endParaRPr lang="en-US" sz="1250" dirty="0"/>
+          </a:p>
+        </p:txBody>
+      </p:sp>
+      <p:sp>
+        <p:nvSpPr>
+          <p:cNvPr id="9" name="Text 6"/>
+          <p:cNvSpPr/>
+          <p:nvPr/>
+        </p:nvSpPr>
+        <p:spPr>
+          <a:xfrm>
+            <a:off x="7269480" y="5029200"/>
+            <a:ext cx="3840480" cy="914400"/>
+          </a:xfrm>
+          <a:prstGeom prst="rect">
+            <a:avLst/>
+          </a:prstGeom>
+          <a:noFill/>
+          <a:ln/>
+        </p:spPr>
+        <p:txBody>
+          <a:bodyPr wrap="square" lIns="0" tIns="0" rIns="0" bIns="0" rtlCol="0" anchor="ctr"/>
+          <a:lstStyle/>
+          <a:p>
+            <a:pPr indent="0" marL="0">
+              <a:buNone/>
+            </a:pPr>
+            <a:r>
+              <a:rPr lang="en-US" sz="1400" dirty="0">
                 <a:solidFill>
                   <a:srgbClr val="EDE7DE"/>
                 </a:solidFill>
@@ -4941,46 +4933,7 @@
                 <a:ea typeface="Calibri" pitchFamily="34" charset="-122"/>
                 <a:cs typeface="Calibri" pitchFamily="34" charset="-120"/>
               </a:rPr>
-              <a:t>Pela primeira vez na história, a fábrica podia ser construída onde a pessoa quisesse — perto do carvão, perto do porto, perto de quem compra.</a:t>
-            </a:r>
-            <a:endParaRPr lang="en-US" sz="1500" dirty="0"/>
-          </a:p>
-        </p:txBody>
-      </p:sp>
-      <p:sp>
-        <p:nvSpPr>
-          <p:cNvPr id="9" name="Text 7"/>
-          <p:cNvSpPr/>
-          <p:nvPr/>
-        </p:nvSpPr>
-        <p:spPr>
-          <a:xfrm>
-            <a:off x="7269480" y="3657600"/>
-            <a:ext cx="3840480" cy="1097280"/>
-          </a:xfrm>
-          <a:prstGeom prst="rect">
-            <a:avLst/>
-          </a:prstGeom>
-          <a:noFill/>
-          <a:ln/>
-        </p:spPr>
-        <p:txBody>
-          <a:bodyPr wrap="square" lIns="0" tIns="0" rIns="0" bIns="0" rtlCol="0" anchor="ctr"/>
-          <a:lstStyle/>
-          <a:p>
-            <a:pPr indent="0" marL="0">
-              <a:buNone/>
-            </a:pPr>
-            <a:r>
-              <a:rPr lang="en-US" sz="1400" i="1" dirty="0">
-                <a:solidFill>
-                  <a:srgbClr val="9A8E82"/>
-                </a:solidFill>
-                <a:latin typeface="Calibri" pitchFamily="34" charset="0"/>
-                <a:ea typeface="Calibri" pitchFamily="34" charset="-122"/>
-                <a:cs typeface="Calibri" pitchFamily="34" charset="-120"/>
-              </a:rPr>
-              <a:t>A força virou um produto que se compra e se transporta. Deixou de ser um acidente geográfico.</a:t>
+              <a:t>A fábrica podia, enfim, ser construída onde a pessoa quisesse: perto do carvão, do porto ou de quem compra.</a:t>
             </a:r>
             <a:endParaRPr lang="en-US" sz="1400" dirty="0"/>
           </a:p>
@@ -6059,8 +6012,8 @@
         </p:nvSpPr>
         <p:spPr>
           <a:xfrm>
-            <a:off x="685800" y="1371600"/>
-            <a:ext cx="5486400" cy="1645920"/>
+            <a:off x="685800" y="1188720"/>
+            <a:ext cx="5120640" cy="1645920"/>
           </a:xfrm>
           <a:prstGeom prst="rect">
             <a:avLst/>
@@ -6074,12 +6027,12 @@
           <a:p>
             <a:pPr indent="0" marL="0">
               <a:lnSpc>
-                <a:spcPts val="4200"/>
+                <a:spcPts val="4000"/>
               </a:lnSpc>
               <a:buNone/>
             </a:pPr>
             <a:r>
-              <a:rPr lang="en-US" sz="3600" b="1" dirty="0">
+              <a:rPr lang="en-US" sz="3400" b="1" dirty="0">
                 <a:solidFill>
                   <a:srgbClr val="EDE7DE"/>
                 </a:solidFill>
@@ -6089,17 +6042,17 @@
               </a:rPr>
               <a:t>O algodão foi o</a:t>
             </a:r>
-            <a:endParaRPr lang="en-US" sz="3600" dirty="0"/>
+            <a:endParaRPr lang="en-US" sz="3400" dirty="0"/>
           </a:p>
           <a:p>
             <a:pPr indent="0" marL="0">
               <a:lnSpc>
-                <a:spcPts val="4200"/>
+                <a:spcPts val="4000"/>
               </a:lnSpc>
               <a:buNone/>
             </a:pPr>
             <a:r>
-              <a:rPr lang="en-US" sz="3600" b="1" dirty="0">
+              <a:rPr lang="en-US" sz="3400" b="1" dirty="0">
                 <a:solidFill>
                   <a:srgbClr val="EDE7DE"/>
                 </a:solidFill>
@@ -6109,7 +6062,7 @@
               </a:rPr>
               <a:t>primeiro teste</a:t>
             </a:r>
-            <a:endParaRPr lang="en-US" sz="3600" dirty="0"/>
+            <a:endParaRPr lang="en-US" sz="3400" dirty="0"/>
           </a:p>
         </p:txBody>
       </p:sp>
@@ -6121,8 +6074,8 @@
         </p:nvSpPr>
         <p:spPr>
           <a:xfrm>
-            <a:off x="685800" y="3154680"/>
-            <a:ext cx="5212080" cy="1280160"/>
+            <a:off x="685800" y="2788920"/>
+            <a:ext cx="4937760" cy="1188720"/>
           </a:xfrm>
           <a:prstGeom prst="rect">
             <a:avLst/>
@@ -6160,8 +6113,8 @@
         </p:nvSpPr>
         <p:spPr>
           <a:xfrm>
-            <a:off x="685800" y="4617720"/>
-            <a:ext cx="5212080" cy="822960"/>
+            <a:off x="685800" y="3977640"/>
+            <a:ext cx="4937760" cy="731520"/>
           </a:xfrm>
           <a:prstGeom prst="rect">
             <a:avLst/>
@@ -6191,20 +6144,83 @@
           </a:p>
         </p:txBody>
       </p:sp>
-      <p:sp>
-        <p:nvSpPr>
-          <p:cNvPr id="6" name="Shape 4"/>
-          <p:cNvSpPr/>
-          <p:nvPr/>
-        </p:nvSpPr>
-        <p:spPr>
-          <a:xfrm>
-            <a:off x="6766560" y="1371600"/>
-            <a:ext cx="4736592" cy="1280160"/>
+      <p:pic>
+        <p:nvPicPr>
+          <p:cNvPr id="6" name="Image 0" descr="/tmp/claude-0/-home-user-industry/243a34b7-d02b-5193-b717-6e82dfe9a345/scratchpad/img/tear.png">    </p:cNvPr>
+          <p:cNvPicPr>
+            <a:picLocks noChangeAspect="1"/>
+          </p:cNvPicPr>
+          <p:nvPr/>
+        </p:nvPicPr>
+        <p:blipFill>
+          <a:blip r:embed="rId1"/>
+          <a:stretch>
+            <a:fillRect/>
+          </a:stretch>
+        </p:blipFill>
+        <p:spPr>
+          <a:xfrm>
+            <a:off x="6858000" y="1051560"/>
+            <a:ext cx="4572000" cy="3483429"/>
+          </a:xfrm>
+          <a:prstGeom prst="rect">
+            <a:avLst/>
+          </a:prstGeom>
+        </p:spPr>
+      </p:pic>
+      <p:sp>
+        <p:nvSpPr>
+          <p:cNvPr id="7" name="Text 4"/>
+          <p:cNvSpPr/>
+          <p:nvPr/>
+        </p:nvSpPr>
+        <p:spPr>
+          <a:xfrm>
+            <a:off x="6858000" y="4526280"/>
+            <a:ext cx="4572000" cy="320040"/>
+          </a:xfrm>
+          <a:prstGeom prst="rect">
+            <a:avLst/>
+          </a:prstGeom>
+          <a:noFill/>
+          <a:ln/>
+        </p:spPr>
+        <p:txBody>
+          <a:bodyPr wrap="square" lIns="0" tIns="0" rIns="0" bIns="0" rtlCol="0" anchor="ctr"/>
+          <a:lstStyle/>
+          <a:p>
+            <a:pPr algn="ctr" indent="0" marL="0">
+              <a:buNone/>
+            </a:pPr>
+            <a:r>
+              <a:rPr lang="en-US" sz="1200" i="1" dirty="0">
+                <a:solidFill>
+                  <a:srgbClr val="9A8E82"/>
+                </a:solidFill>
+                <a:latin typeface="Calibri" pitchFamily="34" charset="0"/>
+                <a:ea typeface="Calibri" pitchFamily="34" charset="-122"/>
+                <a:cs typeface="Calibri" pitchFamily="34" charset="-120"/>
+              </a:rPr>
+              <a:t>O tear mecânico: a lançadeira atravessa os fios sozinha</a:t>
+            </a:r>
+            <a:endParaRPr lang="en-US" sz="1200" dirty="0"/>
+          </a:p>
+        </p:txBody>
+      </p:sp>
+      <p:sp>
+        <p:nvSpPr>
+          <p:cNvPr id="8" name="Shape 5"/>
+          <p:cNvSpPr/>
+          <p:nvPr/>
+        </p:nvSpPr>
+        <p:spPr>
+          <a:xfrm>
+            <a:off x="685800" y="5166360"/>
+            <a:ext cx="3429000" cy="1005840"/>
           </a:xfrm>
           <a:prstGeom prst="roundRect">
             <a:avLst>
-              <a:gd name="adj" fmla="val 7143"/>
+              <a:gd name="adj" fmla="val 9091"/>
             </a:avLst>
           </a:prstGeom>
           <a:solidFill>
@@ -6215,30 +6231,30 @@
       </p:sp>
       <p:sp>
         <p:nvSpPr>
-          <p:cNvPr id="7" name="Text 5"/>
-          <p:cNvSpPr/>
-          <p:nvPr/>
-        </p:nvSpPr>
-        <p:spPr>
-          <a:xfrm>
-            <a:off x="7178040" y="1517904"/>
-            <a:ext cx="3931920" cy="502920"/>
-          </a:xfrm>
-          <a:prstGeom prst="rect">
-            <a:avLst/>
-          </a:prstGeom>
-          <a:noFill/>
-          <a:ln/>
-        </p:spPr>
-        <p:txBody>
-          <a:bodyPr wrap="square" lIns="0" tIns="0" rIns="0" bIns="0" rtlCol="0" anchor="ctr"/>
-          <a:lstStyle/>
-          <a:p>
-            <a:pPr indent="0" marL="0">
-              <a:buNone/>
-            </a:pPr>
-            <a:r>
-              <a:rPr lang="en-US" sz="2600" b="1" dirty="0">
+          <p:cNvPr id="9" name="Text 6"/>
+          <p:cNvSpPr/>
+          <p:nvPr/>
+        </p:nvSpPr>
+        <p:spPr>
+          <a:xfrm>
+            <a:off x="1005840" y="5303520"/>
+            <a:ext cx="2743200" cy="384048"/>
+          </a:xfrm>
+          <a:prstGeom prst="rect">
+            <a:avLst/>
+          </a:prstGeom>
+          <a:noFill/>
+          <a:ln/>
+        </p:spPr>
+        <p:txBody>
+          <a:bodyPr wrap="square" lIns="0" tIns="0" rIns="0" bIns="0" rtlCol="0" anchor="ctr"/>
+          <a:lstStyle/>
+          <a:p>
+            <a:pPr indent="0" marL="0">
+              <a:buNone/>
+            </a:pPr>
+            <a:r>
+              <a:rPr lang="en-US" sz="2000" b="1" dirty="0">
                 <a:solidFill>
                   <a:srgbClr val="D4661F"/>
                 </a:solidFill>
@@ -6248,36 +6264,36 @@
               </a:rPr>
               <a:t>8×</a:t>
             </a:r>
-            <a:endParaRPr lang="en-US" sz="2600" dirty="0"/>
-          </a:p>
-        </p:txBody>
-      </p:sp>
-      <p:sp>
-        <p:nvSpPr>
-          <p:cNvPr id="8" name="Text 6"/>
-          <p:cNvSpPr/>
-          <p:nvPr/>
-        </p:nvSpPr>
-        <p:spPr>
-          <a:xfrm>
-            <a:off x="7178040" y="2066544"/>
-            <a:ext cx="3931920" cy="457200"/>
-          </a:xfrm>
-          <a:prstGeom prst="rect">
-            <a:avLst/>
-          </a:prstGeom>
-          <a:noFill/>
-          <a:ln/>
-        </p:spPr>
-        <p:txBody>
-          <a:bodyPr wrap="square" lIns="0" tIns="0" rIns="0" bIns="0" rtlCol="0" anchor="ctr"/>
-          <a:lstStyle/>
-          <a:p>
-            <a:pPr indent="0" marL="0">
-              <a:buNone/>
-            </a:pPr>
-            <a:r>
-              <a:rPr lang="en-US" sz="1350" dirty="0">
+            <a:endParaRPr lang="en-US" sz="2000" dirty="0"/>
+          </a:p>
+        </p:txBody>
+      </p:sp>
+      <p:sp>
+        <p:nvSpPr>
+          <p:cNvPr id="10" name="Text 7"/>
+          <p:cNvSpPr/>
+          <p:nvPr/>
+        </p:nvSpPr>
+        <p:spPr>
+          <a:xfrm>
+            <a:off x="1005840" y="5705856"/>
+            <a:ext cx="2834640" cy="320040"/>
+          </a:xfrm>
+          <a:prstGeom prst="rect">
+            <a:avLst/>
+          </a:prstGeom>
+          <a:noFill/>
+          <a:ln/>
+        </p:spPr>
+        <p:txBody>
+          <a:bodyPr wrap="square" lIns="0" tIns="0" rIns="0" bIns="0" rtlCol="0" anchor="ctr"/>
+          <a:lstStyle/>
+          <a:p>
+            <a:pPr indent="0" marL="0">
+              <a:buNone/>
+            </a:pPr>
+            <a:r>
+              <a:rPr lang="en-US" sz="1250" dirty="0">
                 <a:solidFill>
                   <a:srgbClr val="EDE7DE"/>
                 </a:solidFill>
@@ -6285,26 +6301,26 @@
                 <a:ea typeface="Calibri" pitchFamily="34" charset="-122"/>
                 <a:cs typeface="Calibri" pitchFamily="34" charset="-120"/>
               </a:rPr>
-              <a:t>mais fios por operário com a spinning jenny</a:t>
-            </a:r>
-            <a:endParaRPr lang="en-US" sz="1350" dirty="0"/>
-          </a:p>
-        </p:txBody>
-      </p:sp>
-      <p:sp>
-        <p:nvSpPr>
-          <p:cNvPr id="9" name="Shape 7"/>
-          <p:cNvSpPr/>
-          <p:nvPr/>
-        </p:nvSpPr>
-        <p:spPr>
-          <a:xfrm>
-            <a:off x="6766560" y="2880360"/>
-            <a:ext cx="4736592" cy="1280160"/>
+              <a:t>mais fios por operário</a:t>
+            </a:r>
+            <a:endParaRPr lang="en-US" sz="1250" dirty="0"/>
+          </a:p>
+        </p:txBody>
+      </p:sp>
+      <p:sp>
+        <p:nvSpPr>
+          <p:cNvPr id="11" name="Shape 8"/>
+          <p:cNvSpPr/>
+          <p:nvPr/>
+        </p:nvSpPr>
+        <p:spPr>
+          <a:xfrm>
+            <a:off x="4361688" y="5166360"/>
+            <a:ext cx="3429000" cy="1005840"/>
           </a:xfrm>
           <a:prstGeom prst="roundRect">
             <a:avLst>
-              <a:gd name="adj" fmla="val 7143"/>
+              <a:gd name="adj" fmla="val 9091"/>
             </a:avLst>
           </a:prstGeom>
           <a:solidFill>
@@ -6315,30 +6331,30 @@
       </p:sp>
       <p:sp>
         <p:nvSpPr>
-          <p:cNvPr id="10" name="Text 8"/>
-          <p:cNvSpPr/>
-          <p:nvPr/>
-        </p:nvSpPr>
-        <p:spPr>
-          <a:xfrm>
-            <a:off x="7178040" y="3026664"/>
-            <a:ext cx="3931920" cy="502920"/>
-          </a:xfrm>
-          <a:prstGeom prst="rect">
-            <a:avLst/>
-          </a:prstGeom>
-          <a:noFill/>
-          <a:ln/>
-        </p:spPr>
-        <p:txBody>
-          <a:bodyPr wrap="square" lIns="0" tIns="0" rIns="0" bIns="0" rtlCol="0" anchor="ctr"/>
-          <a:lstStyle/>
-          <a:p>
-            <a:pPr indent="0" marL="0">
-              <a:buNone/>
-            </a:pPr>
-            <a:r>
-              <a:rPr lang="en-US" sz="2600" b="1" dirty="0">
+          <p:cNvPr id="12" name="Text 9"/>
+          <p:cNvSpPr/>
+          <p:nvPr/>
+        </p:nvSpPr>
+        <p:spPr>
+          <a:xfrm>
+            <a:off x="4681728" y="5303520"/>
+            <a:ext cx="2743200" cy="384048"/>
+          </a:xfrm>
+          <a:prstGeom prst="rect">
+            <a:avLst/>
+          </a:prstGeom>
+          <a:noFill/>
+          <a:ln/>
+        </p:spPr>
+        <p:txBody>
+          <a:bodyPr wrap="square" lIns="0" tIns="0" rIns="0" bIns="0" rtlCol="0" anchor="ctr"/>
+          <a:lstStyle/>
+          <a:p>
+            <a:pPr indent="0" marL="0">
+              <a:buNone/>
+            </a:pPr>
+            <a:r>
+              <a:rPr lang="en-US" sz="2000" b="1" dirty="0">
                 <a:solidFill>
                   <a:srgbClr val="D4661F"/>
                 </a:solidFill>
@@ -6348,36 +6364,36 @@
               </a:rPr>
               <a:t>1 teto</a:t>
             </a:r>
-            <a:endParaRPr lang="en-US" sz="2600" dirty="0"/>
-          </a:p>
-        </p:txBody>
-      </p:sp>
-      <p:sp>
-        <p:nvSpPr>
-          <p:cNvPr id="11" name="Text 9"/>
-          <p:cNvSpPr/>
-          <p:nvPr/>
-        </p:nvSpPr>
-        <p:spPr>
-          <a:xfrm>
-            <a:off x="7178040" y="3575304"/>
-            <a:ext cx="3931920" cy="457200"/>
-          </a:xfrm>
-          <a:prstGeom prst="rect">
-            <a:avLst/>
-          </a:prstGeom>
-          <a:noFill/>
-          <a:ln/>
-        </p:spPr>
-        <p:txBody>
-          <a:bodyPr wrap="square" lIns="0" tIns="0" rIns="0" bIns="0" rtlCol="0" anchor="ctr"/>
-          <a:lstStyle/>
-          <a:p>
-            <a:pPr indent="0" marL="0">
-              <a:buNone/>
-            </a:pPr>
-            <a:r>
-              <a:rPr lang="en-US" sz="1350" dirty="0">
+            <a:endParaRPr lang="en-US" sz="2000" dirty="0"/>
+          </a:p>
+        </p:txBody>
+      </p:sp>
+      <p:sp>
+        <p:nvSpPr>
+          <p:cNvPr id="13" name="Text 10"/>
+          <p:cNvSpPr/>
+          <p:nvPr/>
+        </p:nvSpPr>
+        <p:spPr>
+          <a:xfrm>
+            <a:off x="4681728" y="5705856"/>
+            <a:ext cx="2834640" cy="320040"/>
+          </a:xfrm>
+          <a:prstGeom prst="rect">
+            <a:avLst/>
+          </a:prstGeom>
+          <a:noFill/>
+          <a:ln/>
+        </p:spPr>
+        <p:txBody>
+          <a:bodyPr wrap="square" lIns="0" tIns="0" rIns="0" bIns="0" rtlCol="0" anchor="ctr"/>
+          <a:lstStyle/>
+          <a:p>
+            <a:pPr indent="0" marL="0">
+              <a:buNone/>
+            </a:pPr>
+            <a:r>
+              <a:rPr lang="en-US" sz="1250" dirty="0">
                 <a:solidFill>
                   <a:srgbClr val="EDE7DE"/>
                 </a:solidFill>
@@ -6385,26 +6401,26 @@
                 <a:ea typeface="Calibri" pitchFamily="34" charset="-122"/>
                 <a:cs typeface="Calibri" pitchFamily="34" charset="-120"/>
               </a:rPr>
-              <a:t>máquina, energia e gente no mesmo lugar</a:t>
-            </a:r>
-            <a:endParaRPr lang="en-US" sz="1350" dirty="0"/>
-          </a:p>
-        </p:txBody>
-      </p:sp>
-      <p:sp>
-        <p:nvSpPr>
-          <p:cNvPr id="12" name="Shape 10"/>
-          <p:cNvSpPr/>
-          <p:nvPr/>
-        </p:nvSpPr>
-        <p:spPr>
-          <a:xfrm>
-            <a:off x="6766560" y="4389120"/>
-            <a:ext cx="4736592" cy="1280160"/>
+              <a:t>máquina, energia e gente juntas</a:t>
+            </a:r>
+            <a:endParaRPr lang="en-US" sz="1250" dirty="0"/>
+          </a:p>
+        </p:txBody>
+      </p:sp>
+      <p:sp>
+        <p:nvSpPr>
+          <p:cNvPr id="14" name="Shape 11"/>
+          <p:cNvSpPr/>
+          <p:nvPr/>
+        </p:nvSpPr>
+        <p:spPr>
+          <a:xfrm>
+            <a:off x="8037576" y="5166360"/>
+            <a:ext cx="3429000" cy="1005840"/>
           </a:xfrm>
           <a:prstGeom prst="roundRect">
             <a:avLst>
-              <a:gd name="adj" fmla="val 7143"/>
+              <a:gd name="adj" fmla="val 9091"/>
             </a:avLst>
           </a:prstGeom>
           <a:solidFill>
@@ -6415,30 +6431,30 @@
       </p:sp>
       <p:sp>
         <p:nvSpPr>
-          <p:cNvPr id="13" name="Text 11"/>
-          <p:cNvSpPr/>
-          <p:nvPr/>
-        </p:nvSpPr>
-        <p:spPr>
-          <a:xfrm>
-            <a:off x="7178040" y="4535424"/>
-            <a:ext cx="3931920" cy="502920"/>
-          </a:xfrm>
-          <a:prstGeom prst="rect">
-            <a:avLst/>
-          </a:prstGeom>
-          <a:noFill/>
-          <a:ln/>
-        </p:spPr>
-        <p:txBody>
-          <a:bodyPr wrap="square" lIns="0" tIns="0" rIns="0" bIns="0" rtlCol="0" anchor="ctr"/>
-          <a:lstStyle/>
-          <a:p>
-            <a:pPr indent="0" marL="0">
-              <a:buNone/>
-            </a:pPr>
-            <a:r>
-              <a:rPr lang="en-US" sz="2600" b="1" dirty="0">
+          <p:cNvPr id="15" name="Text 12"/>
+          <p:cNvSpPr/>
+          <p:nvPr/>
+        </p:nvSpPr>
+        <p:spPr>
+          <a:xfrm>
+            <a:off x="8357616" y="5303520"/>
+            <a:ext cx="2743200" cy="384048"/>
+          </a:xfrm>
+          <a:prstGeom prst="rect">
+            <a:avLst/>
+          </a:prstGeom>
+          <a:noFill/>
+          <a:ln/>
+        </p:spPr>
+        <p:txBody>
+          <a:bodyPr wrap="square" lIns="0" tIns="0" rIns="0" bIns="0" rtlCol="0" anchor="ctr"/>
+          <a:lstStyle/>
+          <a:p>
+            <a:pPr indent="0" marL="0">
+              <a:buNone/>
+            </a:pPr>
+            <a:r>
+              <a:rPr lang="en-US" sz="2000" b="1" dirty="0">
                 <a:solidFill>
                   <a:srgbClr val="D4661F"/>
                 </a:solidFill>
@@ -6448,36 +6464,36 @@
               </a:rPr>
               <a:t>24 h</a:t>
             </a:r>
-            <a:endParaRPr lang="en-US" sz="2600" dirty="0"/>
-          </a:p>
-        </p:txBody>
-      </p:sp>
-      <p:sp>
-        <p:nvSpPr>
-          <p:cNvPr id="14" name="Text 12"/>
-          <p:cNvSpPr/>
-          <p:nvPr/>
-        </p:nvSpPr>
-        <p:spPr>
-          <a:xfrm>
-            <a:off x="7178040" y="5084064"/>
-            <a:ext cx="3931920" cy="457200"/>
-          </a:xfrm>
-          <a:prstGeom prst="rect">
-            <a:avLst/>
-          </a:prstGeom>
-          <a:noFill/>
-          <a:ln/>
-        </p:spPr>
-        <p:txBody>
-          <a:bodyPr wrap="square" lIns="0" tIns="0" rIns="0" bIns="0" rtlCol="0" anchor="ctr"/>
-          <a:lstStyle/>
-          <a:p>
-            <a:pPr indent="0" marL="0">
-              <a:buNone/>
-            </a:pPr>
-            <a:r>
-              <a:rPr lang="en-US" sz="1350" dirty="0">
+            <a:endParaRPr lang="en-US" sz="2000" dirty="0"/>
+          </a:p>
+        </p:txBody>
+      </p:sp>
+      <p:sp>
+        <p:nvSpPr>
+          <p:cNvPr id="16" name="Text 13"/>
+          <p:cNvSpPr/>
+          <p:nvPr/>
+        </p:nvSpPr>
+        <p:spPr>
+          <a:xfrm>
+            <a:off x="8357616" y="5705856"/>
+            <a:ext cx="2834640" cy="320040"/>
+          </a:xfrm>
+          <a:prstGeom prst="rect">
+            <a:avLst/>
+          </a:prstGeom>
+          <a:noFill/>
+          <a:ln/>
+        </p:spPr>
+        <p:txBody>
+          <a:bodyPr wrap="square" lIns="0" tIns="0" rIns="0" bIns="0" rtlCol="0" anchor="ctr"/>
+          <a:lstStyle/>
+          <a:p>
+            <a:pPr indent="0" marL="0">
+              <a:buNone/>
+            </a:pPr>
+            <a:r>
+              <a:rPr lang="en-US" sz="1250" dirty="0">
                 <a:solidFill>
                   <a:srgbClr val="EDE7DE"/>
                 </a:solidFill>
@@ -6485,9 +6501,9 @@
                 <a:ea typeface="Calibri" pitchFamily="34" charset="-122"/>
                 <a:cs typeface="Calibri" pitchFamily="34" charset="-120"/>
               </a:rPr>
-              <a:t>a produção deixa de depender da luz do dia</a:t>
-            </a:r>
-            <a:endParaRPr lang="en-US" sz="1350" dirty="0"/>
+              <a:t>produção sem depender do sol</a:t>
+            </a:r>
+            <a:endParaRPr lang="en-US" sz="1250" dirty="0"/>
           </a:p>
         </p:txBody>
       </p:sp>
@@ -6610,7 +6626,7 @@
         <p:spPr>
           <a:xfrm>
             <a:off x="685800" y="1600200"/>
-            <a:ext cx="6400800" cy="1005840"/>
+            <a:ext cx="5760720" cy="1280160"/>
           </a:xfrm>
           <a:prstGeom prst="rect">
             <a:avLst/>
@@ -6640,20 +6656,44 @@
           </a:p>
         </p:txBody>
       </p:sp>
-      <p:sp>
-        <p:nvSpPr>
-          <p:cNvPr id="5" name="Shape 3"/>
-          <p:cNvSpPr/>
-          <p:nvPr/>
-        </p:nvSpPr>
-        <p:spPr>
-          <a:xfrm>
-            <a:off x="685800" y="2834640"/>
-            <a:ext cx="5212080" cy="3108960"/>
+      <p:pic>
+        <p:nvPicPr>
+          <p:cNvPr id="5" name="Image 0" descr="/tmp/claude-0/-home-user-industry/243a34b7-d02b-5193-b717-6e82dfe9a345/scratchpad/img/locomotiva.png">    </p:cNvPr>
+          <p:cNvPicPr>
+            <a:picLocks noChangeAspect="1"/>
+          </p:cNvPicPr>
+          <p:nvPr/>
+        </p:nvPicPr>
+        <p:blipFill>
+          <a:blip r:embed="rId1"/>
+          <a:stretch>
+            <a:fillRect/>
+          </a:stretch>
+        </p:blipFill>
+        <p:spPr>
+          <a:xfrm>
+            <a:off x="7452360" y="1371600"/>
+            <a:ext cx="3108960" cy="2368731"/>
+          </a:xfrm>
+          <a:prstGeom prst="rect">
+            <a:avLst/>
+          </a:prstGeom>
+        </p:spPr>
+      </p:pic>
+      <p:sp>
+        <p:nvSpPr>
+          <p:cNvPr id="6" name="Shape 3"/>
+          <p:cNvSpPr/>
+          <p:nvPr/>
+        </p:nvSpPr>
+        <p:spPr>
+          <a:xfrm>
+            <a:off x="685800" y="3977640"/>
+            <a:ext cx="5212080" cy="1965960"/>
           </a:xfrm>
           <a:prstGeom prst="roundRect">
             <a:avLst>
-              <a:gd name="adj" fmla="val 3529"/>
+              <a:gd name="adj" fmla="val 5581"/>
             </a:avLst>
           </a:prstGeom>
           <a:solidFill>
@@ -6664,23 +6704,23 @@
       </p:sp>
       <p:sp>
         <p:nvSpPr>
-          <p:cNvPr id="6" name="Text 4"/>
-          <p:cNvSpPr/>
-          <p:nvPr/>
-        </p:nvSpPr>
-        <p:spPr>
-          <a:xfrm>
-            <a:off x="1097280" y="3200400"/>
-            <a:ext cx="4389120" cy="320040"/>
-          </a:xfrm>
-          <a:prstGeom prst="rect">
-            <a:avLst/>
-          </a:prstGeom>
-          <a:noFill/>
-          <a:ln/>
-        </p:spPr>
-        <p:txBody>
-          <a:bodyPr wrap="square" lIns="0" tIns="0" rIns="0" bIns="0" rtlCol="0" anchor="ctr"/>
+          <p:cNvPr id="7" name="Text 4"/>
+          <p:cNvSpPr/>
+          <p:nvPr/>
+        </p:nvSpPr>
+        <p:spPr>
+          <a:xfrm>
+            <a:off x="1097280" y="4224528"/>
+            <a:ext cx="4389120" cy="274320"/>
+          </a:xfrm>
+          <a:prstGeom prst="rect">
+            <a:avLst/>
+          </a:prstGeom>
+          <a:noFill/>
+          <a:ln/>
+        </p:spPr>
+        <p:txBody>
+          <a:bodyPr wrap="square" lIns="0" tIns="0" rIns="0" bIns="0" rtlCol="0" anchor="t"/>
           <a:lstStyle/>
           <a:p>
             <a:pPr indent="0" marL="0">
@@ -6703,34 +6743,34 @@
       </p:sp>
       <p:sp>
         <p:nvSpPr>
-          <p:cNvPr id="7" name="Text 5"/>
-          <p:cNvSpPr/>
-          <p:nvPr/>
-        </p:nvSpPr>
-        <p:spPr>
-          <a:xfrm>
-            <a:off x="1097280" y="3703320"/>
-            <a:ext cx="4389120" cy="1920240"/>
-          </a:xfrm>
-          <a:prstGeom prst="rect">
-            <a:avLst/>
-          </a:prstGeom>
-          <a:noFill/>
-          <a:ln/>
-        </p:spPr>
-        <p:txBody>
-          <a:bodyPr wrap="square" lIns="0" tIns="0" rIns="0" bIns="0" rtlCol="0" anchor="ctr"/>
+          <p:cNvPr id="8" name="Text 5"/>
+          <p:cNvSpPr/>
+          <p:nvPr/>
+        </p:nvSpPr>
+        <p:spPr>
+          <a:xfrm>
+            <a:off x="1097280" y="4617720"/>
+            <a:ext cx="4389120" cy="1234440"/>
+          </a:xfrm>
+          <a:prstGeom prst="rect">
+            <a:avLst/>
+          </a:prstGeom>
+          <a:noFill/>
+          <a:ln/>
+        </p:spPr>
+        <p:txBody>
+          <a:bodyPr wrap="square" lIns="0" tIns="0" rIns="0" bIns="0" rtlCol="0" anchor="t"/>
           <a:lstStyle/>
           <a:p>
             <a:pPr marL="342900" indent="-342900">
               <a:spcAft>
-                <a:spcPts val="800"/>
+                <a:spcPts val="600"/>
               </a:spcAft>
               <a:buSzPct val="100000"/>
               <a:buChar char="•"/>
             </a:pPr>
             <a:r>
-              <a:rPr lang="en-US" sz="1450" dirty="0">
+              <a:rPr lang="en-US" sz="1350" dirty="0">
                 <a:solidFill>
                   <a:srgbClr val="EDE7DE"/>
                 </a:solidFill>
@@ -6738,20 +6778,20 @@
                 <a:ea typeface="Calibri" pitchFamily="34" charset="-122"/>
                 <a:cs typeface="Calibri" pitchFamily="34" charset="-120"/>
               </a:rPr>
-              <a:t>Matéria-prima chega mais longe e mais barata</a:t>
-            </a:r>
-            <a:endParaRPr lang="en-US" sz="1450" dirty="0"/>
+              <a:t>Matéria-prima mais longe e mais barata</a:t>
+            </a:r>
+            <a:endParaRPr lang="en-US" sz="1350" dirty="0"/>
           </a:p>
           <a:p>
             <a:pPr marL="342900" indent="-342900">
               <a:spcAft>
-                <a:spcPts val="800"/>
+                <a:spcPts val="600"/>
               </a:spcAft>
               <a:buSzPct val="100000"/>
               <a:buChar char="•"/>
             </a:pPr>
             <a:r>
-              <a:rPr lang="en-US" sz="1450" dirty="0">
+              <a:rPr lang="en-US" sz="1350" dirty="0">
                 <a:solidFill>
                   <a:srgbClr val="EDE7DE"/>
                 </a:solidFill>
@@ -6759,20 +6799,20 @@
                 <a:ea typeface="Calibri" pitchFamily="34" charset="-122"/>
                 <a:cs typeface="Calibri" pitchFamily="34" charset="-120"/>
               </a:rPr>
-              <a:t>A mercadoria alcança mercados de outras cidades</a:t>
-            </a:r>
-            <a:endParaRPr lang="en-US" sz="1450" dirty="0"/>
+              <a:t>A mercadoria alcança outras cidades</a:t>
+            </a:r>
+            <a:endParaRPr lang="en-US" sz="1350" dirty="0"/>
           </a:p>
           <a:p>
             <a:pPr marL="342900" indent="-342900">
               <a:spcAft>
-                <a:spcPts val="800"/>
+                <a:spcPts val="600"/>
               </a:spcAft>
               <a:buSzPct val="100000"/>
               <a:buChar char="•"/>
             </a:pPr>
             <a:r>
-              <a:rPr lang="en-US" sz="1450" dirty="0">
+              <a:rPr lang="en-US" sz="1350" dirty="0">
                 <a:solidFill>
                   <a:srgbClr val="EDE7DE"/>
                 </a:solidFill>
@@ -6780,20 +6820,20 @@
                 <a:ea typeface="Calibri" pitchFamily="34" charset="-122"/>
                 <a:cs typeface="Calibri" pitchFamily="34" charset="-120"/>
               </a:rPr>
-              <a:t>As pessoas passam a se mudar para onde há trabalho</a:t>
-            </a:r>
-            <a:endParaRPr lang="en-US" sz="1450" dirty="0"/>
+              <a:t>Gente se muda para onde há trabalho</a:t>
+            </a:r>
+            <a:endParaRPr lang="en-US" sz="1350" dirty="0"/>
           </a:p>
           <a:p>
             <a:pPr marL="342900" indent="-342900">
               <a:spcAft>
-                <a:spcPts val="800"/>
+                <a:spcPts val="600"/>
               </a:spcAft>
               <a:buSzPct val="100000"/>
               <a:buChar char="•"/>
             </a:pPr>
             <a:r>
-              <a:rPr lang="en-US" sz="1450" dirty="0">
+              <a:rPr lang="en-US" sz="1350" dirty="0">
                 <a:solidFill>
                   <a:srgbClr val="EDE7DE"/>
                 </a:solidFill>
@@ -6801,26 +6841,26 @@
                 <a:ea typeface="Calibri" pitchFamily="34" charset="-122"/>
                 <a:cs typeface="Calibri" pitchFamily="34" charset="-120"/>
               </a:rPr>
-              <a:t>O horário passa a ser padronizado entre cidades</a:t>
-            </a:r>
-            <a:endParaRPr lang="en-US" sz="1450" dirty="0"/>
-          </a:p>
-        </p:txBody>
-      </p:sp>
-      <p:sp>
-        <p:nvSpPr>
-          <p:cNvPr id="8" name="Shape 6"/>
-          <p:cNvSpPr/>
-          <p:nvPr/>
-        </p:nvSpPr>
-        <p:spPr>
-          <a:xfrm>
-            <a:off x="6263640" y="2834640"/>
-            <a:ext cx="5239512" cy="3108960"/>
+              <a:t>O horário é padronizado entre cidades</a:t>
+            </a:r>
+            <a:endParaRPr lang="en-US" sz="1350" dirty="0"/>
+          </a:p>
+        </p:txBody>
+      </p:sp>
+      <p:sp>
+        <p:nvSpPr>
+          <p:cNvPr id="9" name="Shape 6"/>
+          <p:cNvSpPr/>
+          <p:nvPr/>
+        </p:nvSpPr>
+        <p:spPr>
+          <a:xfrm>
+            <a:off x="6263640" y="3977640"/>
+            <a:ext cx="5239512" cy="1965960"/>
           </a:xfrm>
           <a:prstGeom prst="roundRect">
             <a:avLst>
-              <a:gd name="adj" fmla="val 3529"/>
+              <a:gd name="adj" fmla="val 5581"/>
             </a:avLst>
           </a:prstGeom>
           <a:solidFill>
@@ -6831,13 +6871,13 @@
       </p:sp>
       <p:sp>
         <p:nvSpPr>
-          <p:cNvPr id="9" name="Text 7"/>
-          <p:cNvSpPr/>
-          <p:nvPr/>
-        </p:nvSpPr>
-        <p:spPr>
-          <a:xfrm>
-            <a:off x="6675120" y="3291840"/>
+          <p:cNvPr id="10" name="Text 7"/>
+          <p:cNvSpPr/>
+          <p:nvPr/>
+        </p:nvSpPr>
+        <p:spPr>
+          <a:xfrm>
+            <a:off x="6675120" y="4206240"/>
             <a:ext cx="4389120" cy="548640"/>
           </a:xfrm>
           <a:prstGeom prst="rect">
@@ -6870,13 +6910,13 @@
       </p:sp>
       <p:sp>
         <p:nvSpPr>
-          <p:cNvPr id="10" name="Text 8"/>
-          <p:cNvSpPr/>
-          <p:nvPr/>
-        </p:nvSpPr>
-        <p:spPr>
-          <a:xfrm>
-            <a:off x="6675120" y="3840480"/>
+          <p:cNvPr id="11" name="Text 8"/>
+          <p:cNvSpPr/>
+          <p:nvPr/>
+        </p:nvSpPr>
+        <p:spPr>
+          <a:xfrm>
+            <a:off x="6675120" y="4700016"/>
             <a:ext cx="4389120" cy="320040"/>
           </a:xfrm>
           <a:prstGeom prst="rect">
@@ -6909,13 +6949,13 @@
       </p:sp>
       <p:sp>
         <p:nvSpPr>
-          <p:cNvPr id="11" name="Text 9"/>
-          <p:cNvSpPr/>
-          <p:nvPr/>
-        </p:nvSpPr>
-        <p:spPr>
-          <a:xfrm>
-            <a:off x="6675120" y="4480560"/>
+          <p:cNvPr id="12" name="Text 9"/>
+          <p:cNvSpPr/>
+          <p:nvPr/>
+        </p:nvSpPr>
+        <p:spPr>
+          <a:xfrm>
+            <a:off x="6675120" y="5074920"/>
             <a:ext cx="4389120" cy="640080"/>
           </a:xfrm>
           <a:prstGeom prst="rect">
@@ -6948,13 +6988,13 @@
       </p:sp>
       <p:sp>
         <p:nvSpPr>
-          <p:cNvPr id="12" name="Text 10"/>
-          <p:cNvSpPr/>
-          <p:nvPr/>
-        </p:nvSpPr>
-        <p:spPr>
-          <a:xfrm>
-            <a:off x="6675120" y="5138928"/>
+          <p:cNvPr id="13" name="Text 10"/>
+          <p:cNvSpPr/>
+          <p:nvPr/>
+        </p:nvSpPr>
+        <p:spPr>
+          <a:xfrm>
+            <a:off x="6675120" y="5687568"/>
             <a:ext cx="4389120" cy="320040"/>
           </a:xfrm>
           <a:prstGeom prst="rect">

</xml_diff>

<commit_message>
Cola da apresentação em PDF e notas reescritas
As notas de orador dos três slides saem de prosa corrida e viram linhas
curtas de cola, com o tempo de cada slide no topo e uma seção "se travar"
com as perguntas prováveis.

Acrescenta docs/cola-apresentacao.pdf: duas páginas com todo o texto a
ser falado, feito para ler do celular ou impresso na mão. A página de
notas que o PowerPoint exporta corta texto longo — ela não pagina — então
a cola é gerada por fora, a partir de docs/cola-apresentacao.html.

O texto continua fora dos slides projetados, que seguem só com tópicos.
</commit_message>
<xml_diff>
--- a/docs/primeira-revolucao-industrial.pptx
+++ b/docs/primeira-revolucao-industrial.pptx
@@ -504,7 +504,12 @@
           <a:p>
             <a:r>
               <a:rPr lang="en-US" dirty="0"/>
-              <a:t>A imagem é Manchester em 1852, vista do campo. Use ela para abrir: 'olhem o fundo — cada risco daquele é uma chaminé. Em cem anos uma cidade inteira virou isso.' Não leia o slide. Diga o tema e passe. Você tem 30 segundos aqui.</a:t>
+              <a:t>CAPA — 30 segundos. Não leia o título.
+• "Isso é Manchester, na Inglaterra, em 1852, vista do campo."
+• "Olhem o fundo: cada risco daquele é uma chaminé de fábrica."
+• "Em pouco mais de cem anos, uma cidade inteira virou isso."
+• "Meu tema é a Primeira Revolução Industrial, que começou por volta de 1760."
+Passe o slide.</a:t>
             </a:r>
             <a:endParaRPr lang="en-US" dirty="0"/>
           </a:p>
@@ -592,11 +597,30 @@
           <a:p>
             <a:r>
               <a:rPr lang="en-US" dirty="0"/>
-              <a:t>Este é o único slide de conteúdo, então fale com calma sobre os quatro pontos.
-1) Inglaterra, 1760: foi lá porque tinha carvão, ferro e dinheiro de comércio juntos.
-2) A máquina a vapor de James Watt (1769) deu força constante movida a carvão. Antes, a fábrica tinha que ficar na beira de um rio; depois, podia ser construída em qualquer lugar.
-3) Antes o artesão fazia a peça inteira em casa. Depois, máquina, energia e gente ficaram debaixo do mesmo teto — é isso que a gravura mostra. Começou no tecido, porque fiar à mão era o maior gargalo da época.
-4) O preço foi alto: jornada de 14 a 16 horas, trabalho infantil e cidades sem esgoto. Foi daí que nasceram os sindicatos e as primeiras leis trabalhistas.</a:t>
+              <a:t>RESUMO — 3 minutos. É aqui que você segura. Um tópico de cada vez.
+1) INGLATERRA, 1760
+• Foi lá porque três coisas estavam no mesmo lugar: carvão para queimar,
+  ferro para construir máquina, e dinheiro do comércio para investir.
+2) A MÁQUINA A VAPOR
+• Antes, a força vinha de gente e animais, roda d'água ou moinho de vento.
+• Se você queria uma fábrica, tinha que construir na beira de um rio —
+  e se o rio secasse no verão, parava tudo.
+• Em 1769 James Watt melhorou a máquina a vapor: força constante, movida
+  a carvão, a qualquer hora.
+• A fábrica pôde ser construída em qualquer lugar.
+3) A PRODUÇÃO FOI PARA A FÁBRICA   (aponte a gravura aqui)
+• Antes, o artesão fazia a peça inteira sozinho, na própria casa.
+• Depois, máquina, energia e trabalhadores debaixo do mesmo teto.
+• Começou no tecido porque fiar à mão era o maior gargalo da época.
+4) O PREÇO
+• Saíram do campo para morar perto da fábrica, em cidades sem esgoto
+  nem água limpa.
+• Jornada de 14 a 16 horas, seis dias por semana.
+• Criança trabalhava nas máquinas porque era pequena e barata.
+FECHE ASSIM:
+"Foi dessa situação que nasceram os sindicatos e as primeiras leis
+trabalhistas. A mesma revolução que criou a fábrica criou a necessidade
+de proteger quem trabalha nela."</a:t>
             </a:r>
             <a:endParaRPr lang="en-US" dirty="0"/>
           </a:p>
@@ -684,12 +708,40 @@
           <a:p>
             <a:r>
               <a:rPr lang="en-US" dirty="0"/>
-              <a:t>RESPOSTAS CURTAS — fale, não leia o slide.
-1) Tirou o trabalhador do campo e da oficina e o levou para a fábrica: jornada de 14 a 16 horas, trabalho infantil e cidades sem saneamento. Em troca nasceu o emprego assalariado — e, como reação, os sindicatos e as primeiras leis trabalhistas.
-2) Eletricidade, aço barato, petróleo e motor a combustão, linha de montagem de Ford, telégrafo e telefone. Resumo: a produção em massa.
-3) Computador, satélite e internet. A informação deixou de depender de transporte físico: virou instantânea, global e quase de graça. Carta que levava dias virou mensagem em segundos.
-4) Automatiza tarefas repetitivas, inclusive de escritório. Algumas funções somem, outras nascem ligadas a dados e à supervisão das máquinas. Vale mais quem sabe trabalhar junto com a tecnologia, e requalificação virou permanente.
-5) Inteligência artificial, internet das coisas, computação quântica, biotecnologia e edição genética, energias renováveis com armazenamento, e robótica autônoma.</a:t>
+              <a:t>AS CINCO RESPOSTAS — 1 min 30. Leia a pergunta e responda. Não se estenda.
+1) TRABALHADORES NA 1ª
+• Saíram do campo e da oficina para a fábrica.
+• Jornada de 14 a 16 h, trabalho infantil, cidade sem saneamento.
+• Em troca nasceu o emprego assalariado — e, como reação, os sindicatos
+  e as primeiras leis trabalhistas.
+2) INOVAÇÕES DA 2ª
+• Eletricidade, aço barato, petróleo e motor a combustão.
+• Linha de montagem do Ford, telégrafo e telefone.
+• Em duas palavras: produção em massa.
+3) COMUNICAÇÃO NA 3ª
+• Computador, satélite e internet.
+• A informação parou de depender de transporte físico: virou instantânea,
+  global e quase de graça.
+• Carta que levava dias virou mensagem em segundos.
+4) TRABALHO NA 4ª
+• Automatiza tarefa repetitiva, inclusive de escritório.
+• Funções somem, outras nascem ligadas a dados e a cuidar das máquinas.
+• Vale mais quem sabe trabalhar junto com a tecnologia.
+• Estudar virou permanente, não é mais uma fase.
+5) TECNOLOGIAS DO FUTURO
+• Inteligência artificial e internet das coisas.
+• Computação quântica.
+• Biotecnologia e edição genética.
+• Energias renováveis com armazenamento.
+• Robótica autônoma.
+FECHAMENTO (opcional):
+"Toda revolução responde à mesma pergunta: o que ainda está limitando a
+produção. Na primeira faltava força. Hoje falta a máquina decidir sozinha."
+SE TRAVAR:
+• Esqueceu a data? Diga "meados do século XVIII" e siga.
+• Quem inventou a máquina a vapor? Watt não inventou do zero — melhorou
+  a máquina de Thomas Newcomen, de 1712.
+• Por que a Inglaterra? Carvão, ferro e capital de comércio no mesmo lugar.</a:t>
             </a:r>
             <a:endParaRPr lang="en-US" dirty="0"/>
           </a:p>

</xml_diff>

<commit_message>
Explicação de cada tópico dentro do slide
Cada tópico do resumo e cada uma das cinco perguntas passa a ter uma
linha de explicação logo abaixo, em corpo menor e cor mais leve, para
servir de apoio durante a fala sem virar parágrafo.

As notas de orador deixam de repetir o que agora está na tela e ficam só
com o que completa: por que na Inglaterra, o exemplo do rio que seca, a
marcação de apontar a gravura e as frases de fechamento.
</commit_message>
<xml_diff>
--- a/docs/primeira-revolucao-industrial.pptx
+++ b/docs/primeira-revolucao-industrial.pptx
@@ -597,30 +597,12 @@
           <a:p>
             <a:r>
               <a:rPr lang="en-US" dirty="0"/>
-              <a:t>RESUMO — 3 minutos. É aqui que você segura. Um tópico de cada vez.
-1) INGLATERRA, 1760
-• Foi lá porque três coisas estavam no mesmo lugar: carvão para queimar,
-  ferro para construir máquina, e dinheiro do comércio para investir.
-2) A MÁQUINA A VAPOR
-• Antes, a força vinha de gente e animais, roda d'água ou moinho de vento.
-• Se você queria uma fábrica, tinha que construir na beira de um rio —
-  e se o rio secasse no verão, parava tudo.
-• Em 1769 James Watt melhorou a máquina a vapor: força constante, movida
-  a carvão, a qualquer hora.
-• A fábrica pôde ser construída em qualquer lugar.
-3) A PRODUÇÃO FOI PARA A FÁBRICA   (aponte a gravura aqui)
-• Antes, o artesão fazia a peça inteira sozinho, na própria casa.
-• Depois, máquina, energia e trabalhadores debaixo do mesmo teto.
-• Começou no tecido porque fiar à mão era o maior gargalo da época.
-4) O PREÇO
-• Saíram do campo para morar perto da fábrica, em cidades sem esgoto
-  nem água limpa.
-• Jornada de 14 a 16 horas, seis dias por semana.
-• Criança trabalhava nas máquinas porque era pequena e barata.
-FECHE ASSIM:
-"Foi dessa situação que nasceram os sindicatos e as primeiras leis
-trabalhistas. A mesma revolução que criou a fábrica criou a necessidade
-de proteger quem trabalha nela."</a:t>
+              <a:t>RESUMO — 3 minutos. A explicação já está na tela; use as falas abaixo para completar.
+1) Inglaterra tinha carvão para queimar, ferro para construir máquina e capital de comércio para investir.
+2) Antes da máquina a vapor a fábrica tinha que ficar na beira de um rio — e se o rio secasse no verão, parava tudo.
+3) Antes o artesão fazia a peça inteira em casa. Começou no tecido porque fiar à mão era o maior gargalo. (aponte a gravura)
+4) Jornada de 14 a 16 horas, seis dias por semana. Criança trabalhava porque era pequena e barata.
+FECHE: "a mesma revolução que criou a fábrica criou a necessidade de proteger quem trabalha nela."</a:t>
             </a:r>
             <a:endParaRPr lang="en-US" dirty="0"/>
           </a:p>
@@ -708,40 +690,14 @@
           <a:p>
             <a:r>
               <a:rPr lang="en-US" dirty="0"/>
-              <a:t>AS CINCO RESPOSTAS — 1 min 30. Leia a pergunta e responda. Não se estenda.
-1) TRABALHADORES NA 1ª
-• Saíram do campo e da oficina para a fábrica.
-• Jornada de 14 a 16 h, trabalho infantil, cidade sem saneamento.
-• Em troca nasceu o emprego assalariado — e, como reação, os sindicatos
-  e as primeiras leis trabalhistas.
-2) INOVAÇÕES DA 2ª
-• Eletricidade, aço barato, petróleo e motor a combustão.
-• Linha de montagem do Ford, telégrafo e telefone.
-• Em duas palavras: produção em massa.
-3) COMUNICAÇÃO NA 3ª
-• Computador, satélite e internet.
-• A informação parou de depender de transporte físico: virou instantânea,
-  global e quase de graça.
-• Carta que levava dias virou mensagem em segundos.
-4) TRABALHO NA 4ª
-• Automatiza tarefa repetitiva, inclusive de escritório.
-• Funções somem, outras nascem ligadas a dados e a cuidar das máquinas.
-• Vale mais quem sabe trabalhar junto com a tecnologia.
-• Estudar virou permanente, não é mais uma fase.
-5) TECNOLOGIAS DO FUTURO
-• Inteligência artificial e internet das coisas.
-• Computação quântica.
-• Biotecnologia e edição genética.
-• Energias renováveis com armazenamento.
-• Robótica autônoma.
-FECHAMENTO (opcional):
-"Toda revolução responde à mesma pergunta: o que ainda está limitando a
-produção. Na primeira faltava força. Hoje falta a máquina decidir sozinha."
-SE TRAVAR:
-• Esqueceu a data? Diga "meados do século XVIII" e siga.
-• Quem inventou a máquina a vapor? Watt não inventou do zero — melhorou
-  a máquina de Thomas Newcomen, de 1712.
-• Por que a Inglaterra? Carvão, ferro e capital de comércio no mesmo lugar.</a:t>
+              <a:t>AS CINCO RESPOSTAS — a resposta curta já está na tela. Leia a pergunta e desenvolva:
+1) Foi daí que nasceram os sindicatos e as primeiras leis trabalhistas.
+2) Em duas palavras: produção em massa.
+3) Carta que levava dias virou mensagem em segundos.
+4) Vale mais quem sabe trabalhar junto com a tecnologia; estudar virou permanente.
+5) São as tecnologias que ainda estão se firmando agora.
+FECHAMENTO: "toda revolução responde à mesma pergunta — o que ainda limita a produção. Na primeira faltava força. Hoje falta a máquina decidir sozinha."
+SE TRAVAR: Watt não inventou do zero, melhorou a máquina de Newcomen (1712). Foi na Inglaterra porque carvão, ferro e capital estavam no mesmo lugar.</a:t>
             </a:r>
             <a:endParaRPr lang="en-US" dirty="0"/>
           </a:p>
@@ -1515,8 +1471,8 @@
         </p:nvSpPr>
         <p:spPr>
           <a:xfrm>
-            <a:off x="685800" y="2148840"/>
-            <a:ext cx="585216" cy="585216"/>
+            <a:off x="685800" y="1965960"/>
+            <a:ext cx="512064" cy="512064"/>
           </a:xfrm>
           <a:prstGeom prst="ellipse">
             <a:avLst/>
@@ -1535,8 +1491,8 @@
         </p:nvSpPr>
         <p:spPr>
           <a:xfrm>
-            <a:off x="685800" y="2148840"/>
-            <a:ext cx="585216" cy="585216"/>
+            <a:off x="685800" y="1965960"/>
+            <a:ext cx="512064" cy="512064"/>
           </a:xfrm>
           <a:prstGeom prst="rect">
             <a:avLst/>
@@ -1574,24 +1530,24 @@
         </p:nvSpPr>
         <p:spPr>
           <a:xfrm>
-            <a:off x="1600200" y="2148840"/>
-            <a:ext cx="5029200" cy="585216"/>
-          </a:xfrm>
-          <a:prstGeom prst="rect">
-            <a:avLst/>
-          </a:prstGeom>
-          <a:noFill/>
-          <a:ln/>
-        </p:spPr>
-        <p:txBody>
-          <a:bodyPr wrap="square" lIns="0" tIns="0" rIns="0" bIns="0" rtlCol="0" anchor="ctr"/>
+            <a:off x="1463040" y="1938528"/>
+            <a:ext cx="5166360" cy="310896"/>
+          </a:xfrm>
+          <a:prstGeom prst="rect">
+            <a:avLst/>
+          </a:prstGeom>
+          <a:noFill/>
+          <a:ln/>
+        </p:spPr>
+        <p:txBody>
+          <a:bodyPr wrap="square" lIns="0" tIns="0" rIns="0" bIns="0" rtlCol="0" anchor="t"/>
           <a:lstStyle/>
           <a:p>
             <a:pPr indent="0" marL="0">
               <a:buNone/>
             </a:pPr>
             <a:r>
-              <a:rPr lang="en-US" sz="1700" dirty="0">
+              <a:rPr lang="en-US" sz="1550" b="1" dirty="0">
                 <a:solidFill>
                   <a:srgbClr val="1A1614"/>
                 </a:solidFill>
@@ -1601,20 +1557,59 @@
               </a:rPr>
               <a:t>Começou na Inglaterra, por volta de 1760</a:t>
             </a:r>
-            <a:endParaRPr lang="en-US" sz="1700" dirty="0"/>
-          </a:p>
-        </p:txBody>
-      </p:sp>
-      <p:sp>
-        <p:nvSpPr>
-          <p:cNvPr id="7" name="Shape 5"/>
-          <p:cNvSpPr/>
-          <p:nvPr/>
-        </p:nvSpPr>
-        <p:spPr>
-          <a:xfrm>
-            <a:off x="685800" y="3108960"/>
-            <a:ext cx="585216" cy="585216"/>
+            <a:endParaRPr lang="en-US" sz="1550" dirty="0"/>
+          </a:p>
+        </p:txBody>
+      </p:sp>
+      <p:sp>
+        <p:nvSpPr>
+          <p:cNvPr id="7" name="Text 5"/>
+          <p:cNvSpPr/>
+          <p:nvPr/>
+        </p:nvSpPr>
+        <p:spPr>
+          <a:xfrm>
+            <a:off x="1463040" y="2267712"/>
+            <a:ext cx="5166360" cy="566928"/>
+          </a:xfrm>
+          <a:prstGeom prst="rect">
+            <a:avLst/>
+          </a:prstGeom>
+          <a:noFill/>
+          <a:ln/>
+        </p:spPr>
+        <p:txBody>
+          <a:bodyPr wrap="square" lIns="0" tIns="0" rIns="0" bIns="0" rtlCol="0" anchor="t"/>
+          <a:lstStyle/>
+          <a:p>
+            <a:pPr indent="0" marL="0">
+              <a:buNone/>
+            </a:pPr>
+            <a:r>
+              <a:rPr lang="en-US" sz="1250" dirty="0">
+                <a:solidFill>
+                  <a:srgbClr val="5A514A"/>
+                </a:solidFill>
+                <a:latin typeface="Calibri" pitchFamily="34" charset="0"/>
+                <a:ea typeface="Calibri" pitchFamily="34" charset="-122"/>
+                <a:cs typeface="Calibri" pitchFamily="34" charset="-120"/>
+              </a:rPr>
+              <a:t>Carvão, ferro e dinheiro do comércio estavam todos no mesmo lugar.</a:t>
+            </a:r>
+            <a:endParaRPr lang="en-US" sz="1250" dirty="0"/>
+          </a:p>
+        </p:txBody>
+      </p:sp>
+      <p:sp>
+        <p:nvSpPr>
+          <p:cNvPr id="8" name="Shape 6"/>
+          <p:cNvSpPr/>
+          <p:nvPr/>
+        </p:nvSpPr>
+        <p:spPr>
+          <a:xfrm>
+            <a:off x="685800" y="3017520"/>
+            <a:ext cx="512064" cy="512064"/>
           </a:xfrm>
           <a:prstGeom prst="ellipse">
             <a:avLst/>
@@ -1627,14 +1622,14 @@
       </p:sp>
       <p:sp>
         <p:nvSpPr>
-          <p:cNvPr id="8" name="Text 6"/>
-          <p:cNvSpPr/>
-          <p:nvPr/>
-        </p:nvSpPr>
-        <p:spPr>
-          <a:xfrm>
-            <a:off x="685800" y="3108960"/>
-            <a:ext cx="585216" cy="585216"/>
+          <p:cNvPr id="9" name="Text 7"/>
+          <p:cNvSpPr/>
+          <p:nvPr/>
+        </p:nvSpPr>
+        <p:spPr>
+          <a:xfrm>
+            <a:off x="685800" y="3017520"/>
+            <a:ext cx="512064" cy="512064"/>
           </a:xfrm>
           <a:prstGeom prst="rect">
             <a:avLst/>
@@ -1666,30 +1661,30 @@
       </p:sp>
       <p:sp>
         <p:nvSpPr>
-          <p:cNvPr id="9" name="Text 7"/>
-          <p:cNvSpPr/>
-          <p:nvPr/>
-        </p:nvSpPr>
-        <p:spPr>
-          <a:xfrm>
-            <a:off x="1600200" y="3108960"/>
-            <a:ext cx="5029200" cy="585216"/>
-          </a:xfrm>
-          <a:prstGeom prst="rect">
-            <a:avLst/>
-          </a:prstGeom>
-          <a:noFill/>
-          <a:ln/>
-        </p:spPr>
-        <p:txBody>
-          <a:bodyPr wrap="square" lIns="0" tIns="0" rIns="0" bIns="0" rtlCol="0" anchor="ctr"/>
+          <p:cNvPr id="10" name="Text 8"/>
+          <p:cNvSpPr/>
+          <p:nvPr/>
+        </p:nvSpPr>
+        <p:spPr>
+          <a:xfrm>
+            <a:off x="1463040" y="2990088"/>
+            <a:ext cx="5166360" cy="310896"/>
+          </a:xfrm>
+          <a:prstGeom prst="rect">
+            <a:avLst/>
+          </a:prstGeom>
+          <a:noFill/>
+          <a:ln/>
+        </p:spPr>
+        <p:txBody>
+          <a:bodyPr wrap="square" lIns="0" tIns="0" rIns="0" bIns="0" rtlCol="0" anchor="t"/>
           <a:lstStyle/>
           <a:p>
             <a:pPr indent="0" marL="0">
               <a:buNone/>
             </a:pPr>
             <a:r>
-              <a:rPr lang="en-US" sz="1700" dirty="0">
+              <a:rPr lang="en-US" sz="1550" b="1" dirty="0">
                 <a:solidFill>
                   <a:srgbClr val="1A1614"/>
                 </a:solidFill>
@@ -1699,20 +1694,59 @@
               </a:rPr>
               <a:t>Máquina a vapor no lugar de músculo e água</a:t>
             </a:r>
-            <a:endParaRPr lang="en-US" sz="1700" dirty="0"/>
-          </a:p>
-        </p:txBody>
-      </p:sp>
-      <p:sp>
-        <p:nvSpPr>
-          <p:cNvPr id="10" name="Shape 8"/>
+            <a:endParaRPr lang="en-US" sz="1550" dirty="0"/>
+          </a:p>
+        </p:txBody>
+      </p:sp>
+      <p:sp>
+        <p:nvSpPr>
+          <p:cNvPr id="11" name="Text 9"/>
+          <p:cNvSpPr/>
+          <p:nvPr/>
+        </p:nvSpPr>
+        <p:spPr>
+          <a:xfrm>
+            <a:off x="1463040" y="3319272"/>
+            <a:ext cx="5166360" cy="566928"/>
+          </a:xfrm>
+          <a:prstGeom prst="rect">
+            <a:avLst/>
+          </a:prstGeom>
+          <a:noFill/>
+          <a:ln/>
+        </p:spPr>
+        <p:txBody>
+          <a:bodyPr wrap="square" lIns="0" tIns="0" rIns="0" bIns="0" rtlCol="0" anchor="t"/>
+          <a:lstStyle/>
+          <a:p>
+            <a:pPr indent="0" marL="0">
+              <a:buNone/>
+            </a:pPr>
+            <a:r>
+              <a:rPr lang="en-US" sz="1250" dirty="0">
+                <a:solidFill>
+                  <a:srgbClr val="5A514A"/>
+                </a:solidFill>
+                <a:latin typeface="Calibri" pitchFamily="34" charset="0"/>
+                <a:ea typeface="Calibri" pitchFamily="34" charset="-122"/>
+                <a:cs typeface="Calibri" pitchFamily="34" charset="-120"/>
+              </a:rPr>
+              <a:t>Watt, em 1769: força constante movida a carvão, longe de qualquer rio.</a:t>
+            </a:r>
+            <a:endParaRPr lang="en-US" sz="1250" dirty="0"/>
+          </a:p>
+        </p:txBody>
+      </p:sp>
+      <p:sp>
+        <p:nvSpPr>
+          <p:cNvPr id="12" name="Shape 10"/>
           <p:cNvSpPr/>
           <p:nvPr/>
         </p:nvSpPr>
         <p:spPr>
           <a:xfrm>
             <a:off x="685800" y="4069080"/>
-            <a:ext cx="585216" cy="585216"/>
+            <a:ext cx="512064" cy="512064"/>
           </a:xfrm>
           <a:prstGeom prst="ellipse">
             <a:avLst/>
@@ -1725,14 +1759,14 @@
       </p:sp>
       <p:sp>
         <p:nvSpPr>
-          <p:cNvPr id="11" name="Text 9"/>
+          <p:cNvPr id="13" name="Text 11"/>
           <p:cNvSpPr/>
           <p:nvPr/>
         </p:nvSpPr>
         <p:spPr>
           <a:xfrm>
             <a:off x="685800" y="4069080"/>
-            <a:ext cx="585216" cy="585216"/>
+            <a:ext cx="512064" cy="512064"/>
           </a:xfrm>
           <a:prstGeom prst="rect">
             <a:avLst/>
@@ -1764,30 +1798,30 @@
       </p:sp>
       <p:sp>
         <p:nvSpPr>
-          <p:cNvPr id="12" name="Text 10"/>
-          <p:cNvSpPr/>
-          <p:nvPr/>
-        </p:nvSpPr>
-        <p:spPr>
-          <a:xfrm>
-            <a:off x="1600200" y="4069080"/>
-            <a:ext cx="5029200" cy="585216"/>
-          </a:xfrm>
-          <a:prstGeom prst="rect">
-            <a:avLst/>
-          </a:prstGeom>
-          <a:noFill/>
-          <a:ln/>
-        </p:spPr>
-        <p:txBody>
-          <a:bodyPr wrap="square" lIns="0" tIns="0" rIns="0" bIns="0" rtlCol="0" anchor="ctr"/>
+          <p:cNvPr id="14" name="Text 12"/>
+          <p:cNvSpPr/>
+          <p:nvPr/>
+        </p:nvSpPr>
+        <p:spPr>
+          <a:xfrm>
+            <a:off x="1463040" y="4041648"/>
+            <a:ext cx="5166360" cy="310896"/>
+          </a:xfrm>
+          <a:prstGeom prst="rect">
+            <a:avLst/>
+          </a:prstGeom>
+          <a:noFill/>
+          <a:ln/>
+        </p:spPr>
+        <p:txBody>
+          <a:bodyPr wrap="square" lIns="0" tIns="0" rIns="0" bIns="0" rtlCol="0" anchor="t"/>
           <a:lstStyle/>
           <a:p>
             <a:pPr indent="0" marL="0">
               <a:buNone/>
             </a:pPr>
             <a:r>
-              <a:rPr lang="en-US" sz="1700" dirty="0">
+              <a:rPr lang="en-US" sz="1550" b="1" dirty="0">
                 <a:solidFill>
                   <a:srgbClr val="1A1614"/>
                 </a:solidFill>
@@ -1797,20 +1831,59 @@
               </a:rPr>
               <a:t>A produção saiu de casa e foi para a fábrica</a:t>
             </a:r>
-            <a:endParaRPr lang="en-US" sz="1700" dirty="0"/>
-          </a:p>
-        </p:txBody>
-      </p:sp>
-      <p:sp>
-        <p:nvSpPr>
-          <p:cNvPr id="13" name="Shape 11"/>
-          <p:cNvSpPr/>
-          <p:nvPr/>
-        </p:nvSpPr>
-        <p:spPr>
-          <a:xfrm>
-            <a:off x="685800" y="5029200"/>
-            <a:ext cx="585216" cy="585216"/>
+            <a:endParaRPr lang="en-US" sz="1550" dirty="0"/>
+          </a:p>
+        </p:txBody>
+      </p:sp>
+      <p:sp>
+        <p:nvSpPr>
+          <p:cNvPr id="15" name="Text 13"/>
+          <p:cNvSpPr/>
+          <p:nvPr/>
+        </p:nvSpPr>
+        <p:spPr>
+          <a:xfrm>
+            <a:off x="1463040" y="4370832"/>
+            <a:ext cx="5166360" cy="566928"/>
+          </a:xfrm>
+          <a:prstGeom prst="rect">
+            <a:avLst/>
+          </a:prstGeom>
+          <a:noFill/>
+          <a:ln/>
+        </p:spPr>
+        <p:txBody>
+          <a:bodyPr wrap="square" lIns="0" tIns="0" rIns="0" bIns="0" rtlCol="0" anchor="t"/>
+          <a:lstStyle/>
+          <a:p>
+            <a:pPr indent="0" marL="0">
+              <a:buNone/>
+            </a:pPr>
+            <a:r>
+              <a:rPr lang="en-US" sz="1250" dirty="0">
+                <a:solidFill>
+                  <a:srgbClr val="5A514A"/>
+                </a:solidFill>
+                <a:latin typeface="Calibri" pitchFamily="34" charset="0"/>
+                <a:ea typeface="Calibri" pitchFamily="34" charset="-122"/>
+                <a:cs typeface="Calibri" pitchFamily="34" charset="-120"/>
+              </a:rPr>
+              <a:t>Máquina, energia e trabalhadores debaixo do mesmo teto.</a:t>
+            </a:r>
+            <a:endParaRPr lang="en-US" sz="1250" dirty="0"/>
+          </a:p>
+        </p:txBody>
+      </p:sp>
+      <p:sp>
+        <p:nvSpPr>
+          <p:cNvPr id="16" name="Shape 14"/>
+          <p:cNvSpPr/>
+          <p:nvPr/>
+        </p:nvSpPr>
+        <p:spPr>
+          <a:xfrm>
+            <a:off x="685800" y="5120640"/>
+            <a:ext cx="512064" cy="512064"/>
           </a:xfrm>
           <a:prstGeom prst="ellipse">
             <a:avLst/>
@@ -1823,14 +1896,14 @@
       </p:sp>
       <p:sp>
         <p:nvSpPr>
-          <p:cNvPr id="14" name="Text 12"/>
-          <p:cNvSpPr/>
-          <p:nvPr/>
-        </p:nvSpPr>
-        <p:spPr>
-          <a:xfrm>
-            <a:off x="685800" y="5029200"/>
-            <a:ext cx="585216" cy="585216"/>
+          <p:cNvPr id="17" name="Text 15"/>
+          <p:cNvSpPr/>
+          <p:nvPr/>
+        </p:nvSpPr>
+        <p:spPr>
+          <a:xfrm>
+            <a:off x="685800" y="5120640"/>
+            <a:ext cx="512064" cy="512064"/>
           </a:xfrm>
           <a:prstGeom prst="rect">
             <a:avLst/>
@@ -1862,30 +1935,30 @@
       </p:sp>
       <p:sp>
         <p:nvSpPr>
-          <p:cNvPr id="15" name="Text 13"/>
-          <p:cNvSpPr/>
-          <p:nvPr/>
-        </p:nvSpPr>
-        <p:spPr>
-          <a:xfrm>
-            <a:off x="1600200" y="5029200"/>
-            <a:ext cx="5029200" cy="585216"/>
-          </a:xfrm>
-          <a:prstGeom prst="rect">
-            <a:avLst/>
-          </a:prstGeom>
-          <a:noFill/>
-          <a:ln/>
-        </p:spPr>
-        <p:txBody>
-          <a:bodyPr wrap="square" lIns="0" tIns="0" rIns="0" bIns="0" rtlCol="0" anchor="ctr"/>
+          <p:cNvPr id="18" name="Text 16"/>
+          <p:cNvSpPr/>
+          <p:nvPr/>
+        </p:nvSpPr>
+        <p:spPr>
+          <a:xfrm>
+            <a:off x="1463040" y="5093208"/>
+            <a:ext cx="5166360" cy="310896"/>
+          </a:xfrm>
+          <a:prstGeom prst="rect">
+            <a:avLst/>
+          </a:prstGeom>
+          <a:noFill/>
+          <a:ln/>
+        </p:spPr>
+        <p:txBody>
+          <a:bodyPr wrap="square" lIns="0" tIns="0" rIns="0" bIns="0" rtlCol="0" anchor="t"/>
           <a:lstStyle/>
           <a:p>
             <a:pPr indent="0" marL="0">
               <a:buNone/>
             </a:pPr>
             <a:r>
-              <a:rPr lang="en-US" sz="1700" dirty="0">
+              <a:rPr lang="en-US" sz="1550" b="1" dirty="0">
                 <a:solidFill>
                   <a:srgbClr val="1A1614"/>
                 </a:solidFill>
@@ -1895,13 +1968,52 @@
               </a:rPr>
               <a:t>Do campo para a cidade, com jornada de 16 h</a:t>
             </a:r>
-            <a:endParaRPr lang="en-US" sz="1700" dirty="0"/>
+            <a:endParaRPr lang="en-US" sz="1550" dirty="0"/>
+          </a:p>
+        </p:txBody>
+      </p:sp>
+      <p:sp>
+        <p:nvSpPr>
+          <p:cNvPr id="19" name="Text 17"/>
+          <p:cNvSpPr/>
+          <p:nvPr/>
+        </p:nvSpPr>
+        <p:spPr>
+          <a:xfrm>
+            <a:off x="1463040" y="5422392"/>
+            <a:ext cx="5166360" cy="566928"/>
+          </a:xfrm>
+          <a:prstGeom prst="rect">
+            <a:avLst/>
+          </a:prstGeom>
+          <a:noFill/>
+          <a:ln/>
+        </p:spPr>
+        <p:txBody>
+          <a:bodyPr wrap="square" lIns="0" tIns="0" rIns="0" bIns="0" rtlCol="0" anchor="t"/>
+          <a:lstStyle/>
+          <a:p>
+            <a:pPr indent="0" marL="0">
+              <a:buNone/>
+            </a:pPr>
+            <a:r>
+              <a:rPr lang="en-US" sz="1250" dirty="0">
+                <a:solidFill>
+                  <a:srgbClr val="5A514A"/>
+                </a:solidFill>
+                <a:latin typeface="Calibri" pitchFamily="34" charset="0"/>
+                <a:ea typeface="Calibri" pitchFamily="34" charset="-122"/>
+                <a:cs typeface="Calibri" pitchFamily="34" charset="-120"/>
+              </a:rPr>
+              <a:t>Trabalho infantil e cidade sem esgoto. Daí nasceram os sindicatos.</a:t>
+            </a:r>
+            <a:endParaRPr lang="en-US" sz="1250" dirty="0"/>
           </a:p>
         </p:txBody>
       </p:sp>
       <p:pic>
         <p:nvPicPr>
-          <p:cNvPr id="16" name="Image 0" descr="/tmp/claude-0/-home-user-industry/243a34b7-d02b-5193-b717-6e82dfe9a345/scratchpad/hist/tear1835.jpg">    </p:cNvPr>
+          <p:cNvPr id="20" name="Image 0" descr="/tmp/claude-0/-home-user-industry/243a34b7-d02b-5193-b717-6e82dfe9a345/scratchpad/hist/tear1835.jpg">    </p:cNvPr>
           <p:cNvPicPr>
             <a:picLocks noChangeAspect="1"/>
           </p:cNvPicPr>
@@ -1915,7 +2027,7 @@
         </p:blipFill>
         <p:spPr>
           <a:xfrm>
-            <a:off x="6675120" y="2057400"/>
+            <a:off x="6675120" y="1965960"/>
             <a:ext cx="4828032" cy="3118884"/>
           </a:xfrm>
           <a:prstGeom prst="rect">
@@ -1925,13 +2037,13 @@
       </p:pic>
       <p:sp>
         <p:nvSpPr>
-          <p:cNvPr id="17" name="Text 14"/>
-          <p:cNvSpPr/>
-          <p:nvPr/>
-        </p:nvSpPr>
-        <p:spPr>
-          <a:xfrm>
-            <a:off x="6675120" y="5303520"/>
+          <p:cNvPr id="21" name="Text 18"/>
+          <p:cNvSpPr/>
+          <p:nvPr/>
+        </p:nvSpPr>
+        <p:spPr>
+          <a:xfrm>
+            <a:off x="6675120" y="5193792"/>
             <a:ext cx="4828032" cy="274320"/>
           </a:xfrm>
           <a:prstGeom prst="rect">
@@ -2080,8 +2192,8 @@
         </p:nvSpPr>
         <p:spPr>
           <a:xfrm>
-            <a:off x="685800" y="2057400"/>
-            <a:ext cx="548640" cy="548640"/>
+            <a:off x="685800" y="1828800"/>
+            <a:ext cx="475488" cy="475488"/>
           </a:xfrm>
           <a:prstGeom prst="ellipse">
             <a:avLst/>
@@ -2100,8 +2212,8 @@
         </p:nvSpPr>
         <p:spPr>
           <a:xfrm>
-            <a:off x="685800" y="2057400"/>
-            <a:ext cx="548640" cy="548640"/>
+            <a:off x="685800" y="1828800"/>
+            <a:ext cx="475488" cy="475488"/>
           </a:xfrm>
           <a:prstGeom prst="rect">
             <a:avLst/>
@@ -2139,24 +2251,24 @@
         </p:nvSpPr>
         <p:spPr>
           <a:xfrm>
-            <a:off x="1554480" y="2057400"/>
-            <a:ext cx="10058400" cy="548640"/>
-          </a:xfrm>
-          <a:prstGeom prst="rect">
-            <a:avLst/>
-          </a:prstGeom>
-          <a:noFill/>
-          <a:ln/>
-        </p:spPr>
-        <p:txBody>
-          <a:bodyPr wrap="square" lIns="0" tIns="0" rIns="0" bIns="0" rtlCol="0" anchor="ctr"/>
+            <a:off x="1435608" y="1792224"/>
+            <a:ext cx="10241280" cy="310896"/>
+          </a:xfrm>
+          <a:prstGeom prst="rect">
+            <a:avLst/>
+          </a:prstGeom>
+          <a:noFill/>
+          <a:ln/>
+        </p:spPr>
+        <p:txBody>
+          <a:bodyPr wrap="square" lIns="0" tIns="0" rIns="0" bIns="0" rtlCol="0" anchor="t"/>
           <a:lstStyle/>
           <a:p>
             <a:pPr indent="0" marL="0">
               <a:buNone/>
             </a:pPr>
             <a:r>
-              <a:rPr lang="en-US" sz="1700" dirty="0">
+              <a:rPr lang="en-US" sz="1550" b="1" dirty="0">
                 <a:solidFill>
                   <a:srgbClr val="EDE7DE"/>
                 </a:solidFill>
@@ -2166,20 +2278,59 @@
               </a:rPr>
               <a:t>Como a 1ª Revolução impactou a vida dos trabalhadores?</a:t>
             </a:r>
-            <a:endParaRPr lang="en-US" sz="1700" dirty="0"/>
-          </a:p>
-        </p:txBody>
-      </p:sp>
-      <p:sp>
-        <p:nvSpPr>
-          <p:cNvPr id="7" name="Shape 5"/>
-          <p:cNvSpPr/>
-          <p:nvPr/>
-        </p:nvSpPr>
-        <p:spPr>
-          <a:xfrm>
-            <a:off x="685800" y="2880360"/>
-            <a:ext cx="548640" cy="548640"/>
+            <a:endParaRPr lang="en-US" sz="1550" dirty="0"/>
+          </a:p>
+        </p:txBody>
+      </p:sp>
+      <p:sp>
+        <p:nvSpPr>
+          <p:cNvPr id="7" name="Text 5"/>
+          <p:cNvSpPr/>
+          <p:nvPr/>
+        </p:nvSpPr>
+        <p:spPr>
+          <a:xfrm>
+            <a:off x="1435608" y="2130552"/>
+            <a:ext cx="10241280" cy="329184"/>
+          </a:xfrm>
+          <a:prstGeom prst="rect">
+            <a:avLst/>
+          </a:prstGeom>
+          <a:noFill/>
+          <a:ln/>
+        </p:spPr>
+        <p:txBody>
+          <a:bodyPr wrap="square" lIns="0" tIns="0" rIns="0" bIns="0" rtlCol="0" anchor="t"/>
+          <a:lstStyle/>
+          <a:p>
+            <a:pPr indent="0" marL="0">
+              <a:buNone/>
+            </a:pPr>
+            <a:r>
+              <a:rPr lang="en-US" sz="1250" dirty="0">
+                <a:solidFill>
+                  <a:srgbClr val="9A8E82"/>
+                </a:solidFill>
+                <a:latin typeface="Calibri" pitchFamily="34" charset="0"/>
+                <a:ea typeface="Calibri" pitchFamily="34" charset="-122"/>
+                <a:cs typeface="Calibri" pitchFamily="34" charset="-120"/>
+              </a:rPr>
+              <a:t>Do campo para a fábrica: 14 a 16 h, trabalho infantil, cidade sem esgoto. Em troca, o emprego assalariado.</a:t>
+            </a:r>
+            <a:endParaRPr lang="en-US" sz="1250" dirty="0"/>
+          </a:p>
+        </p:txBody>
+      </p:sp>
+      <p:sp>
+        <p:nvSpPr>
+          <p:cNvPr id="8" name="Shape 6"/>
+          <p:cNvSpPr/>
+          <p:nvPr/>
+        </p:nvSpPr>
+        <p:spPr>
+          <a:xfrm>
+            <a:off x="685800" y="2724912"/>
+            <a:ext cx="475488" cy="475488"/>
           </a:xfrm>
           <a:prstGeom prst="ellipse">
             <a:avLst/>
@@ -2192,14 +2343,14 @@
       </p:sp>
       <p:sp>
         <p:nvSpPr>
-          <p:cNvPr id="8" name="Text 6"/>
-          <p:cNvSpPr/>
-          <p:nvPr/>
-        </p:nvSpPr>
-        <p:spPr>
-          <a:xfrm>
-            <a:off x="685800" y="2880360"/>
-            <a:ext cx="548640" cy="548640"/>
+          <p:cNvPr id="9" name="Text 7"/>
+          <p:cNvSpPr/>
+          <p:nvPr/>
+        </p:nvSpPr>
+        <p:spPr>
+          <a:xfrm>
+            <a:off x="685800" y="2724912"/>
+            <a:ext cx="475488" cy="475488"/>
           </a:xfrm>
           <a:prstGeom prst="rect">
             <a:avLst/>
@@ -2231,30 +2382,30 @@
       </p:sp>
       <p:sp>
         <p:nvSpPr>
-          <p:cNvPr id="9" name="Text 7"/>
-          <p:cNvSpPr/>
-          <p:nvPr/>
-        </p:nvSpPr>
-        <p:spPr>
-          <a:xfrm>
-            <a:off x="1554480" y="2880360"/>
-            <a:ext cx="10058400" cy="548640"/>
-          </a:xfrm>
-          <a:prstGeom prst="rect">
-            <a:avLst/>
-          </a:prstGeom>
-          <a:noFill/>
-          <a:ln/>
-        </p:spPr>
-        <p:txBody>
-          <a:bodyPr wrap="square" lIns="0" tIns="0" rIns="0" bIns="0" rtlCol="0" anchor="ctr"/>
+          <p:cNvPr id="10" name="Text 8"/>
+          <p:cNvSpPr/>
+          <p:nvPr/>
+        </p:nvSpPr>
+        <p:spPr>
+          <a:xfrm>
+            <a:off x="1435608" y="2688336"/>
+            <a:ext cx="10241280" cy="310896"/>
+          </a:xfrm>
+          <a:prstGeom prst="rect">
+            <a:avLst/>
+          </a:prstGeom>
+          <a:noFill/>
+          <a:ln/>
+        </p:spPr>
+        <p:txBody>
+          <a:bodyPr wrap="square" lIns="0" tIns="0" rIns="0" bIns="0" rtlCol="0" anchor="t"/>
           <a:lstStyle/>
           <a:p>
             <a:pPr indent="0" marL="0">
               <a:buNone/>
             </a:pPr>
             <a:r>
-              <a:rPr lang="en-US" sz="1700" dirty="0">
+              <a:rPr lang="en-US" sz="1550" b="1" dirty="0">
                 <a:solidFill>
                   <a:srgbClr val="EDE7DE"/>
                 </a:solidFill>
@@ -2264,20 +2415,59 @@
               </a:rPr>
               <a:t>Quais foram as principais inovações da 2ª Revolução?</a:t>
             </a:r>
-            <a:endParaRPr lang="en-US" sz="1700" dirty="0"/>
-          </a:p>
-        </p:txBody>
-      </p:sp>
-      <p:sp>
-        <p:nvSpPr>
-          <p:cNvPr id="10" name="Shape 8"/>
-          <p:cNvSpPr/>
-          <p:nvPr/>
-        </p:nvSpPr>
-        <p:spPr>
-          <a:xfrm>
-            <a:off x="685800" y="3703320"/>
-            <a:ext cx="548640" cy="548640"/>
+            <a:endParaRPr lang="en-US" sz="1550" dirty="0"/>
+          </a:p>
+        </p:txBody>
+      </p:sp>
+      <p:sp>
+        <p:nvSpPr>
+          <p:cNvPr id="11" name="Text 9"/>
+          <p:cNvSpPr/>
+          <p:nvPr/>
+        </p:nvSpPr>
+        <p:spPr>
+          <a:xfrm>
+            <a:off x="1435608" y="3026664"/>
+            <a:ext cx="10241280" cy="329184"/>
+          </a:xfrm>
+          <a:prstGeom prst="rect">
+            <a:avLst/>
+          </a:prstGeom>
+          <a:noFill/>
+          <a:ln/>
+        </p:spPr>
+        <p:txBody>
+          <a:bodyPr wrap="square" lIns="0" tIns="0" rIns="0" bIns="0" rtlCol="0" anchor="t"/>
+          <a:lstStyle/>
+          <a:p>
+            <a:pPr indent="0" marL="0">
+              <a:buNone/>
+            </a:pPr>
+            <a:r>
+              <a:rPr lang="en-US" sz="1250" dirty="0">
+                <a:solidFill>
+                  <a:srgbClr val="9A8E82"/>
+                </a:solidFill>
+                <a:latin typeface="Calibri" pitchFamily="34" charset="0"/>
+                <a:ea typeface="Calibri" pitchFamily="34" charset="-122"/>
+                <a:cs typeface="Calibri" pitchFamily="34" charset="-120"/>
+              </a:rPr>
+              <a:t>Eletricidade, aço, petróleo, motor a combustão, linha de montagem, telégrafo e telefone: a produção em massa.</a:t>
+            </a:r>
+            <a:endParaRPr lang="en-US" sz="1250" dirty="0"/>
+          </a:p>
+        </p:txBody>
+      </p:sp>
+      <p:sp>
+        <p:nvSpPr>
+          <p:cNvPr id="12" name="Shape 10"/>
+          <p:cNvSpPr/>
+          <p:nvPr/>
+        </p:nvSpPr>
+        <p:spPr>
+          <a:xfrm>
+            <a:off x="685800" y="3621024"/>
+            <a:ext cx="475488" cy="475488"/>
           </a:xfrm>
           <a:prstGeom prst="ellipse">
             <a:avLst/>
@@ -2290,14 +2480,14 @@
       </p:sp>
       <p:sp>
         <p:nvSpPr>
-          <p:cNvPr id="11" name="Text 9"/>
-          <p:cNvSpPr/>
-          <p:nvPr/>
-        </p:nvSpPr>
-        <p:spPr>
-          <a:xfrm>
-            <a:off x="685800" y="3703320"/>
-            <a:ext cx="548640" cy="548640"/>
+          <p:cNvPr id="13" name="Text 11"/>
+          <p:cNvSpPr/>
+          <p:nvPr/>
+        </p:nvSpPr>
+        <p:spPr>
+          <a:xfrm>
+            <a:off x="685800" y="3621024"/>
+            <a:ext cx="475488" cy="475488"/>
           </a:xfrm>
           <a:prstGeom prst="rect">
             <a:avLst/>
@@ -2329,30 +2519,30 @@
       </p:sp>
       <p:sp>
         <p:nvSpPr>
-          <p:cNvPr id="12" name="Text 10"/>
-          <p:cNvSpPr/>
-          <p:nvPr/>
-        </p:nvSpPr>
-        <p:spPr>
-          <a:xfrm>
-            <a:off x="1554480" y="3703320"/>
-            <a:ext cx="10058400" cy="548640"/>
-          </a:xfrm>
-          <a:prstGeom prst="rect">
-            <a:avLst/>
-          </a:prstGeom>
-          <a:noFill/>
-          <a:ln/>
-        </p:spPr>
-        <p:txBody>
-          <a:bodyPr wrap="square" lIns="0" tIns="0" rIns="0" bIns="0" rtlCol="0" anchor="ctr"/>
+          <p:cNvPr id="14" name="Text 12"/>
+          <p:cNvSpPr/>
+          <p:nvPr/>
+        </p:nvSpPr>
+        <p:spPr>
+          <a:xfrm>
+            <a:off x="1435608" y="3584448"/>
+            <a:ext cx="10241280" cy="310896"/>
+          </a:xfrm>
+          <a:prstGeom prst="rect">
+            <a:avLst/>
+          </a:prstGeom>
+          <a:noFill/>
+          <a:ln/>
+        </p:spPr>
+        <p:txBody>
+          <a:bodyPr wrap="square" lIns="0" tIns="0" rIns="0" bIns="0" rtlCol="0" anchor="t"/>
           <a:lstStyle/>
           <a:p>
             <a:pPr indent="0" marL="0">
               <a:buNone/>
             </a:pPr>
             <a:r>
-              <a:rPr lang="en-US" sz="1700" dirty="0">
+              <a:rPr lang="en-US" sz="1550" b="1" dirty="0">
                 <a:solidFill>
                   <a:srgbClr val="EDE7DE"/>
                 </a:solidFill>
@@ -2362,20 +2552,59 @@
               </a:rPr>
               <a:t>De que forma a 3ª Revolução transformou a comunicação?</a:t>
             </a:r>
-            <a:endParaRPr lang="en-US" sz="1700" dirty="0"/>
-          </a:p>
-        </p:txBody>
-      </p:sp>
-      <p:sp>
-        <p:nvSpPr>
-          <p:cNvPr id="13" name="Shape 11"/>
-          <p:cNvSpPr/>
-          <p:nvPr/>
-        </p:nvSpPr>
-        <p:spPr>
-          <a:xfrm>
-            <a:off x="685800" y="4526280"/>
-            <a:ext cx="548640" cy="548640"/>
+            <a:endParaRPr lang="en-US" sz="1550" dirty="0"/>
+          </a:p>
+        </p:txBody>
+      </p:sp>
+      <p:sp>
+        <p:nvSpPr>
+          <p:cNvPr id="15" name="Text 13"/>
+          <p:cNvSpPr/>
+          <p:nvPr/>
+        </p:nvSpPr>
+        <p:spPr>
+          <a:xfrm>
+            <a:off x="1435608" y="3922776"/>
+            <a:ext cx="10241280" cy="329184"/>
+          </a:xfrm>
+          <a:prstGeom prst="rect">
+            <a:avLst/>
+          </a:prstGeom>
+          <a:noFill/>
+          <a:ln/>
+        </p:spPr>
+        <p:txBody>
+          <a:bodyPr wrap="square" lIns="0" tIns="0" rIns="0" bIns="0" rtlCol="0" anchor="t"/>
+          <a:lstStyle/>
+          <a:p>
+            <a:pPr indent="0" marL="0">
+              <a:buNone/>
+            </a:pPr>
+            <a:r>
+              <a:rPr lang="en-US" sz="1250" dirty="0">
+                <a:solidFill>
+                  <a:srgbClr val="9A8E82"/>
+                </a:solidFill>
+                <a:latin typeface="Calibri" pitchFamily="34" charset="0"/>
+                <a:ea typeface="Calibri" pitchFamily="34" charset="-122"/>
+                <a:cs typeface="Calibri" pitchFamily="34" charset="-120"/>
+              </a:rPr>
+              <a:t>Computador, satélite e internet. A informação virou instantânea, global e quase de graça.</a:t>
+            </a:r>
+            <a:endParaRPr lang="en-US" sz="1250" dirty="0"/>
+          </a:p>
+        </p:txBody>
+      </p:sp>
+      <p:sp>
+        <p:nvSpPr>
+          <p:cNvPr id="16" name="Shape 14"/>
+          <p:cNvSpPr/>
+          <p:nvPr/>
+        </p:nvSpPr>
+        <p:spPr>
+          <a:xfrm>
+            <a:off x="685800" y="4517136"/>
+            <a:ext cx="475488" cy="475488"/>
           </a:xfrm>
           <a:prstGeom prst="ellipse">
             <a:avLst/>
@@ -2388,14 +2617,14 @@
       </p:sp>
       <p:sp>
         <p:nvSpPr>
-          <p:cNvPr id="14" name="Text 12"/>
-          <p:cNvSpPr/>
-          <p:nvPr/>
-        </p:nvSpPr>
-        <p:spPr>
-          <a:xfrm>
-            <a:off x="685800" y="4526280"/>
-            <a:ext cx="548640" cy="548640"/>
+          <p:cNvPr id="17" name="Text 15"/>
+          <p:cNvSpPr/>
+          <p:nvPr/>
+        </p:nvSpPr>
+        <p:spPr>
+          <a:xfrm>
+            <a:off x="685800" y="4517136"/>
+            <a:ext cx="475488" cy="475488"/>
           </a:xfrm>
           <a:prstGeom prst="rect">
             <a:avLst/>
@@ -2427,30 +2656,30 @@
       </p:sp>
       <p:sp>
         <p:nvSpPr>
-          <p:cNvPr id="15" name="Text 13"/>
-          <p:cNvSpPr/>
-          <p:nvPr/>
-        </p:nvSpPr>
-        <p:spPr>
-          <a:xfrm>
-            <a:off x="1554480" y="4526280"/>
-            <a:ext cx="10058400" cy="548640"/>
-          </a:xfrm>
-          <a:prstGeom prst="rect">
-            <a:avLst/>
-          </a:prstGeom>
-          <a:noFill/>
-          <a:ln/>
-        </p:spPr>
-        <p:txBody>
-          <a:bodyPr wrap="square" lIns="0" tIns="0" rIns="0" bIns="0" rtlCol="0" anchor="ctr"/>
+          <p:cNvPr id="18" name="Text 16"/>
+          <p:cNvSpPr/>
+          <p:nvPr/>
+        </p:nvSpPr>
+        <p:spPr>
+          <a:xfrm>
+            <a:off x="1435608" y="4480560"/>
+            <a:ext cx="10241280" cy="310896"/>
+          </a:xfrm>
+          <a:prstGeom prst="rect">
+            <a:avLst/>
+          </a:prstGeom>
+          <a:noFill/>
+          <a:ln/>
+        </p:spPr>
+        <p:txBody>
+          <a:bodyPr wrap="square" lIns="0" tIns="0" rIns="0" bIns="0" rtlCol="0" anchor="t"/>
           <a:lstStyle/>
           <a:p>
             <a:pPr indent="0" marL="0">
               <a:buNone/>
             </a:pPr>
             <a:r>
-              <a:rPr lang="en-US" sz="1700" dirty="0">
+              <a:rPr lang="en-US" sz="1550" b="1" dirty="0">
                 <a:solidFill>
                   <a:srgbClr val="EDE7DE"/>
                 </a:solidFill>
@@ -2460,20 +2689,59 @@
               </a:rPr>
               <a:t>Como a 4ª Revolução influencia o mercado de trabalho?</a:t>
             </a:r>
-            <a:endParaRPr lang="en-US" sz="1700" dirty="0"/>
-          </a:p>
-        </p:txBody>
-      </p:sp>
-      <p:sp>
-        <p:nvSpPr>
-          <p:cNvPr id="16" name="Shape 14"/>
-          <p:cNvSpPr/>
-          <p:nvPr/>
-        </p:nvSpPr>
-        <p:spPr>
-          <a:xfrm>
-            <a:off x="685800" y="5349240"/>
-            <a:ext cx="548640" cy="548640"/>
+            <a:endParaRPr lang="en-US" sz="1550" dirty="0"/>
+          </a:p>
+        </p:txBody>
+      </p:sp>
+      <p:sp>
+        <p:nvSpPr>
+          <p:cNvPr id="19" name="Text 17"/>
+          <p:cNvSpPr/>
+          <p:nvPr/>
+        </p:nvSpPr>
+        <p:spPr>
+          <a:xfrm>
+            <a:off x="1435608" y="4818888"/>
+            <a:ext cx="10241280" cy="329184"/>
+          </a:xfrm>
+          <a:prstGeom prst="rect">
+            <a:avLst/>
+          </a:prstGeom>
+          <a:noFill/>
+          <a:ln/>
+        </p:spPr>
+        <p:txBody>
+          <a:bodyPr wrap="square" lIns="0" tIns="0" rIns="0" bIns="0" rtlCol="0" anchor="t"/>
+          <a:lstStyle/>
+          <a:p>
+            <a:pPr indent="0" marL="0">
+              <a:buNone/>
+            </a:pPr>
+            <a:r>
+              <a:rPr lang="en-US" sz="1250" dirty="0">
+                <a:solidFill>
+                  <a:srgbClr val="9A8E82"/>
+                </a:solidFill>
+                <a:latin typeface="Calibri" pitchFamily="34" charset="0"/>
+                <a:ea typeface="Calibri" pitchFamily="34" charset="-122"/>
+                <a:cs typeface="Calibri" pitchFamily="34" charset="-120"/>
+              </a:rPr>
+              <a:t>Automatiza tarefa repetitiva. Funções somem, outras nascem ligadas a dados. Requalificação virou permanente.</a:t>
+            </a:r>
+            <a:endParaRPr lang="en-US" sz="1250" dirty="0"/>
+          </a:p>
+        </p:txBody>
+      </p:sp>
+      <p:sp>
+        <p:nvSpPr>
+          <p:cNvPr id="20" name="Shape 18"/>
+          <p:cNvSpPr/>
+          <p:nvPr/>
+        </p:nvSpPr>
+        <p:spPr>
+          <a:xfrm>
+            <a:off x="685800" y="5413248"/>
+            <a:ext cx="475488" cy="475488"/>
           </a:xfrm>
           <a:prstGeom prst="ellipse">
             <a:avLst/>
@@ -2486,14 +2754,14 @@
       </p:sp>
       <p:sp>
         <p:nvSpPr>
-          <p:cNvPr id="17" name="Text 15"/>
-          <p:cNvSpPr/>
-          <p:nvPr/>
-        </p:nvSpPr>
-        <p:spPr>
-          <a:xfrm>
-            <a:off x="685800" y="5349240"/>
-            <a:ext cx="548640" cy="548640"/>
+          <p:cNvPr id="21" name="Text 19"/>
+          <p:cNvSpPr/>
+          <p:nvPr/>
+        </p:nvSpPr>
+        <p:spPr>
+          <a:xfrm>
+            <a:off x="685800" y="5413248"/>
+            <a:ext cx="475488" cy="475488"/>
           </a:xfrm>
           <a:prstGeom prst="rect">
             <a:avLst/>
@@ -2525,30 +2793,30 @@
       </p:sp>
       <p:sp>
         <p:nvSpPr>
-          <p:cNvPr id="18" name="Text 16"/>
-          <p:cNvSpPr/>
-          <p:nvPr/>
-        </p:nvSpPr>
-        <p:spPr>
-          <a:xfrm>
-            <a:off x="1554480" y="5349240"/>
-            <a:ext cx="10058400" cy="548640"/>
-          </a:xfrm>
-          <a:prstGeom prst="rect">
-            <a:avLst/>
-          </a:prstGeom>
-          <a:noFill/>
-          <a:ln/>
-        </p:spPr>
-        <p:txBody>
-          <a:bodyPr wrap="square" lIns="0" tIns="0" rIns="0" bIns="0" rtlCol="0" anchor="ctr"/>
+          <p:cNvPr id="22" name="Text 20"/>
+          <p:cNvSpPr/>
+          <p:nvPr/>
+        </p:nvSpPr>
+        <p:spPr>
+          <a:xfrm>
+            <a:off x="1435608" y="5376672"/>
+            <a:ext cx="10241280" cy="310896"/>
+          </a:xfrm>
+          <a:prstGeom prst="rect">
+            <a:avLst/>
+          </a:prstGeom>
+          <a:noFill/>
+          <a:ln/>
+        </p:spPr>
+        <p:txBody>
+          <a:bodyPr wrap="square" lIns="0" tIns="0" rIns="0" bIns="0" rtlCol="0" anchor="t"/>
           <a:lstStyle/>
           <a:p>
             <a:pPr indent="0" marL="0">
               <a:buNone/>
             </a:pPr>
             <a:r>
-              <a:rPr lang="en-US" sz="1700" dirty="0">
+              <a:rPr lang="en-US" sz="1550" b="1" dirty="0">
                 <a:solidFill>
                   <a:srgbClr val="EDE7DE"/>
                 </a:solidFill>
@@ -2558,19 +2826,58 @@
               </a:rPr>
               <a:t>Quais tecnologias emergentes podem definir o futuro?</a:t>
             </a:r>
-            <a:endParaRPr lang="en-US" sz="1700" dirty="0"/>
-          </a:p>
-        </p:txBody>
-      </p:sp>
-      <p:sp>
-        <p:nvSpPr>
-          <p:cNvPr id="19" name="Text 17"/>
-          <p:cNvSpPr/>
-          <p:nvPr/>
-        </p:nvSpPr>
-        <p:spPr>
-          <a:xfrm>
-            <a:off x="685800" y="6263640"/>
+            <a:endParaRPr lang="en-US" sz="1550" dirty="0"/>
+          </a:p>
+        </p:txBody>
+      </p:sp>
+      <p:sp>
+        <p:nvSpPr>
+          <p:cNvPr id="23" name="Text 21"/>
+          <p:cNvSpPr/>
+          <p:nvPr/>
+        </p:nvSpPr>
+        <p:spPr>
+          <a:xfrm>
+            <a:off x="1435608" y="5715000"/>
+            <a:ext cx="10241280" cy="329184"/>
+          </a:xfrm>
+          <a:prstGeom prst="rect">
+            <a:avLst/>
+          </a:prstGeom>
+          <a:noFill/>
+          <a:ln/>
+        </p:spPr>
+        <p:txBody>
+          <a:bodyPr wrap="square" lIns="0" tIns="0" rIns="0" bIns="0" rtlCol="0" anchor="t"/>
+          <a:lstStyle/>
+          <a:p>
+            <a:pPr indent="0" marL="0">
+              <a:buNone/>
+            </a:pPr>
+            <a:r>
+              <a:rPr lang="en-US" sz="1250" dirty="0">
+                <a:solidFill>
+                  <a:srgbClr val="9A8E82"/>
+                </a:solidFill>
+                <a:latin typeface="Calibri" pitchFamily="34" charset="0"/>
+                <a:ea typeface="Calibri" pitchFamily="34" charset="-122"/>
+                <a:cs typeface="Calibri" pitchFamily="34" charset="-120"/>
+              </a:rPr>
+              <a:t>IA, internet das coisas, computação quântica, biotecnologia, energias renováveis e robótica autônoma.</a:t>
+            </a:r>
+            <a:endParaRPr lang="en-US" sz="1250" dirty="0"/>
+          </a:p>
+        </p:txBody>
+      </p:sp>
+      <p:sp>
+        <p:nvSpPr>
+          <p:cNvPr id="24" name="Text 22"/>
+          <p:cNvSpPr/>
+          <p:nvPr/>
+        </p:nvSpPr>
+        <p:spPr>
+          <a:xfrm>
+            <a:off x="685800" y="6355080"/>
             <a:ext cx="10789920" cy="274320"/>
           </a:xfrm>
           <a:prstGeom prst="rect">

</xml_diff>